<commit_message>
Expand 3-minute deck with report charts and a full speaking script
Co-authored-by: Bhupraj Tamang <BhuprajTmg@users.noreply.github.com>
</commit_message>
<xml_diff>
--- a/WC2026_3min.pptx
+++ b/WC2026_3min.pptx
@@ -11,6 +11,8 @@
     <p:sldId id="259" r:id="rId11"/>
     <p:sldId id="260" r:id="rId12"/>
     <p:sldId id="261" r:id="rId13"/>
+    <p:sldId id="262" r:id="rId14"/>
+    <p:sldId id="263" r:id="rId15"/>
   </p:sldIdLst>
   <p:sldSz cx="12191695" cy="6858000" type="screen4x3"/>
   <p:notesSz cx="6858000" cy="9144000"/>
@@ -507,7 +509,13 @@
           <a:lstStyle/>
           <a:p>
             <a:r>
-              <a:t>0:00–0:20  Open: This is a 3-minute briefing on FIFA World Cup 2026. Spain beat Argentina 1–0 in extra time. We asked four distinct statistical questions and built two linear models using only information available before kickoff.</a:t>
+              <a:t>Good morning. This is a three-minute briefing on World Cup 2026 — the first forty-eight-team tournament, won by Spain, one-nil after extra time against Argentina.</a:t>
+            </a:r>
+          </a:p>
+          <a:p/>
+          <a:p>
+            <a:r>
+              <a:t>We asked four distinct statistical questions, each with a different focal point, and we built two linear models that try to predict the score using only information you could have known before kickoff.</a:t>
             </a:r>
           </a:p>
         </p:txBody>
@@ -577,7 +585,13 @@
           <a:lstStyle/>
           <a:p>
             <a:r>
-              <a:t>0:20–0:45  Data: 104 official matches, 48 teams, 1,016 players who actually appeared. Sources: FIFA, Wikipedia, Transfermarkt, fotmob. Every Objective 1 task follows the same six skills. Both regressions use only variables knowable before kickoff — no shots, no possession.</a:t>
+              <a:t>The data are real: one hundred and four matches, forty-eight teams, and one thousand and sixteen players who actually appeared.</a:t>
+            </a:r>
+          </a:p>
+          <a:p/>
+          <a:p>
+            <a:r>
+              <a:t>Every Objective 1 task follows the same path: a question, a sample, descriptive statistics, a ninety-five percent confidence interval, and a t-test at alpha 0.05. Objective 2 then asks: if you only know ranking, squad value, age, host status and rest days before the match, how well can you predict the result?</a:t>
             </a:r>
           </a:p>
         </p:txBody>
@@ -647,7 +661,13 @@
           <a:lstStyle/>
           <a:p>
             <a:r>
-              <a:t>0:45–1:25  Two popular stories failed. Midfielders 0.10 yellows per appearance vs defenders 0.13 — not significant. Knockout attendance 67,700 vs group 65,700 — also not significant. Say: the expanded World Cup did not have empty group games.</a:t>
+              <a:t>First: are midfielders booked more than defenders? People assume they are because they fight for the ball in midfield. We used yellow cards per appearance, so a seven-match finalist is not punished for playing more, and we sampled forty-five players from each position.</a:t>
+            </a:r>
+          </a:p>
+          <a:p/>
+          <a:p>
+            <a:r>
+              <a:t>Look at the histogram — both groups pile up at zero. Means are 0.10 versus 0.13. p is 0.45, so we fail to reject the null. The “dirty midfield” story is not supported.</a:t>
             </a:r>
           </a:p>
         </p:txBody>
@@ -717,7 +737,13 @@
           <a:lstStyle/>
           <a:p>
             <a:r>
-              <a:t>1:25–2:10  Two results that did land. UEFA squads about 2.6 times more valuable — p=0.004, large effect. Goalkeepers average 30.3 years, significantly older than 27, and 3.6 years older than outfield players. Mention Ochoa at 40 if you have a second.</a:t>
+              <a:t>Second: did knockouts draw bigger crowds? With forty-eight teams you might expect thin weekday group games. We compared all thirty-two knockout matches with a random sample of thirty-two group matches.</a:t>
+            </a:r>
+          </a:p>
+          <a:p/>
+          <a:p>
+            <a:r>
+              <a:t>The box plots sit on top of each other: about sixty-eight thousand versus sixty-six thousand. p is 0.38. Not significant. This World Cup filled stadiums from match one.</a:t>
             </a:r>
           </a:p>
         </p:txBody>
@@ -787,7 +813,13 @@
           <a:lstStyle/>
           <a:p>
             <a:r>
-              <a:t>2:10–2:50  Two models, eight pre-match variables each. Goal difference: training R² 0.49. Significant: ranking gap and market-value gap. Team goals: R² 0.29 — opponent rank and own value. Stress: nothing from during the match is used. Host and rest days drop out once rank and money are controlled.</a:t>
+              <a:t>Third: money. Are UEFA squads worth more on Transfermarkt? Fourteen European teams against fourteen from the rest of the world.</a:t>
+            </a:r>
+          </a:p>
+          <a:p/>
+          <a:p>
+            <a:r>
+              <a:t>The gap is large: six hundred and seventy million euros against two hundred and fifty-seven million — about two and a half times. p is 0.004, a large effect. Europe’s club market really does show up in national-team squads.</a:t>
             </a:r>
           </a:p>
         </p:txBody>
@@ -857,7 +889,165 @@
           <a:lstStyle/>
           <a:p>
             <a:r>
-              <a:t>2:50–3:00  Close on three lines: crowds were full from day one; UEFA squads are far richer; before a match, FIFA rank and squad value are what move the scoreline — not host status or rest days. Stop. Invite questions.</a:t>
+              <a:t>Fourth: do goalkeepers last longer? We tested keepers who appeared against the usual outfield “prime” of twenty-seven, and against outfield teammates.</a:t>
+            </a:r>
+          </a:p>
+          <a:p/>
+          <a:p>
+            <a:r>
+              <a:t>The dashed line on the chart is twenty-seven. The keeper box sits clearly above it, at 30.3 years. p is 0.0001. They are also about three and a half years older than outfield players. That longer shelf life is real.</a:t>
+            </a:r>
+          </a:p>
+        </p:txBody>
+      </p:sp>
+      <p:sp>
+        <p:nvSpPr>
+          <p:cNvPr id="4" name="Slide Number Placeholder 3"/>
+          <p:cNvSpPr>
+            <a:spLocks noGrp="1"/>
+          </p:cNvSpPr>
+          <p:nvPr>
+            <p:ph type="sldNum" idx="5" sz="quarter"/>
+          </p:nvPr>
+        </p:nvSpPr>
+        <p:spPr/>
+      </p:sp>
+    </p:spTree>
+  </p:cSld>
+  <p:clrMapOvr>
+    <a:masterClrMapping/>
+  </p:clrMapOvr>
+</p:notes>
+</file>
+
+<file path=ppt/notesSlides/notesSlide7.xml><?xml version="1.0" encoding="utf-8"?>
+<p:notes xmlns:a="http://schemas.openxmlformats.org/drawingml/2006/main" xmlns:p="http://schemas.openxmlformats.org/presentationml/2006/main" xmlns:r="http://schemas.openxmlformats.org/officeDocument/2006/relationships">
+  <p:cSld>
+    <p:spTree>
+      <p:nvGrpSpPr>
+        <p:cNvPr id="1" name=""/>
+        <p:cNvGrpSpPr/>
+        <p:nvPr/>
+      </p:nvGrpSpPr>
+      <p:grpSpPr>
+        <a:xfrm>
+          <a:off x="0" y="0"/>
+          <a:ext cx="0" cy="0"/>
+          <a:chOff x="0" y="0"/>
+          <a:chExt cx="0" cy="0"/>
+        </a:xfrm>
+      </p:grpSpPr>
+      <p:sp>
+        <p:nvSpPr>
+          <p:cNvPr id="2" name="Slide Image Placeholder 1"/>
+          <p:cNvSpPr>
+            <a:spLocks noGrp="1"/>
+          </p:cNvSpPr>
+          <p:nvPr>
+            <p:ph type="sldImg" idx="2"/>
+          </p:nvPr>
+        </p:nvSpPr>
+        <p:spPr/>
+      </p:sp>
+      <p:sp>
+        <p:nvSpPr>
+          <p:cNvPr id="3" name="Notes Placeholder 2"/>
+          <p:cNvSpPr>
+            <a:spLocks noGrp="1"/>
+          </p:cNvSpPr>
+          <p:nvPr>
+            <p:ph type="body" idx="3" sz="quarter"/>
+          </p:nvPr>
+        </p:nvSpPr>
+        <p:spPr/>
+        <p:txBody>
+          <a:bodyPr/>
+          <a:lstStyle/>
+          <a:p>
+            <a:r>
+              <a:t>Now the two models. Eight predictors each, all knowable before kickoff — no shots, no possession.</a:t>
+            </a:r>
+          </a:p>
+          <a:p/>
+          <a:p>
+            <a:r>
+              <a:t>On the left, goal difference across one hundred and four matches. R-squared 0.49. Typical error about one and a half goals. What mattered: ranking gap and squad-value gap. Host, rest and age dropped out.</a:t>
+            </a:r>
+          </a:p>
+          <a:p/>
+          <a:p>
+            <a:r>
+              <a:t>On the right, goals scored by a team, two hundred and eight rows. R-squared 0.29 — noisier, because one tally is harder than a difference. What mattered: opponent’s rank and own squad value. The scatter plots are the held-out tests: they follow the diagonal, with the noise you expect from football.</a:t>
+            </a:r>
+          </a:p>
+        </p:txBody>
+      </p:sp>
+      <p:sp>
+        <p:nvSpPr>
+          <p:cNvPr id="4" name="Slide Number Placeholder 3"/>
+          <p:cNvSpPr>
+            <a:spLocks noGrp="1"/>
+          </p:cNvSpPr>
+          <p:nvPr>
+            <p:ph type="sldNum" idx="5" sz="quarter"/>
+          </p:nvPr>
+        </p:nvSpPr>
+        <p:spPr/>
+      </p:sp>
+    </p:spTree>
+  </p:cSld>
+  <p:clrMapOvr>
+    <a:masterClrMapping/>
+  </p:clrMapOvr>
+</p:notes>
+</file>
+
+<file path=ppt/notesSlides/notesSlide8.xml><?xml version="1.0" encoding="utf-8"?>
+<p:notes xmlns:a="http://schemas.openxmlformats.org/drawingml/2006/main" xmlns:p="http://schemas.openxmlformats.org/presentationml/2006/main" xmlns:r="http://schemas.openxmlformats.org/officeDocument/2006/relationships">
+  <p:cSld>
+    <p:spTree>
+      <p:nvGrpSpPr>
+        <p:cNvPr id="1" name=""/>
+        <p:cNvGrpSpPr/>
+        <p:nvPr/>
+      </p:nvGrpSpPr>
+      <p:grpSpPr>
+        <a:xfrm>
+          <a:off x="0" y="0"/>
+          <a:ext cx="0" cy="0"/>
+          <a:chOff x="0" y="0"/>
+          <a:chExt cx="0" cy="0"/>
+        </a:xfrm>
+      </p:grpSpPr>
+      <p:sp>
+        <p:nvSpPr>
+          <p:cNvPr id="2" name="Slide Image Placeholder 1"/>
+          <p:cNvSpPr>
+            <a:spLocks noGrp="1"/>
+          </p:cNvSpPr>
+          <p:nvPr>
+            <p:ph type="sldImg" idx="2"/>
+          </p:nvPr>
+        </p:nvSpPr>
+        <p:spPr/>
+      </p:sp>
+      <p:sp>
+        <p:nvSpPr>
+          <p:cNvPr id="3" name="Notes Placeholder 2"/>
+          <p:cNvSpPr>
+            <a:spLocks noGrp="1"/>
+          </p:cNvSpPr>
+          <p:nvPr>
+            <p:ph type="body" idx="3" sz="quarter"/>
+          </p:nvPr>
+        </p:nvSpPr>
+        <p:spPr/>
+        <p:txBody>
+          <a:bodyPr/>
+          <a:lstStyle/>
+          <a:p>
+            <a:r>
+              <a:t>Three takeaways. Crowds did not wait for knockouts. Europe’s money is a real gap. And before a match, rank and squad value — not rest days or host status — are what move the scoreline. Thank you.</a:t>
             </a:r>
           </a:p>
         </p:txBody>
@@ -4000,8 +4190,8 @@
         </p:nvSpPr>
         <p:spPr>
           <a:xfrm>
-            <a:off x="777240" y="1417320"/>
-            <a:ext cx="10515600" cy="365760"/>
+            <a:off x="731520" y="1325880"/>
+            <a:ext cx="10607040" cy="4114800"/>
           </a:xfrm>
           <a:prstGeom prst="rect">
             <a:avLst/>
@@ -4016,7 +4206,7 @@
           <a:p>
             <a:pPr algn="l">
               <a:spcAft>
-                <a:spcPts val="400"/>
+                <a:spcPts val="1400"/>
               </a:spcAft>
             </a:pPr>
             <a:r>
@@ -4026,32 +4216,73 @@
                 </a:solidFill>
                 <a:latin typeface="Calibri"/>
               </a:rPr>
-              <a:t>HIT140  ·  3-MINUTE BRIEFING</a:t>
-            </a:r>
-          </a:p>
-        </p:txBody>
-      </p:sp>
-      <p:sp>
-        <p:nvSpPr>
-          <p:cNvPr id="6" name="TextBox 5"/>
-          <p:cNvSpPr txBox="1"/>
-          <p:nvPr/>
-        </p:nvSpPr>
-        <p:spPr>
-          <a:xfrm>
-            <a:off x="731520" y="1874519"/>
-            <a:ext cx="10607040" cy="2011680"/>
-          </a:xfrm>
-          <a:prstGeom prst="rect">
-            <a:avLst/>
-          </a:prstGeom>
-          <a:noFill/>
-        </p:spPr>
-        <p:txBody>
-          <a:bodyPr wrap="square">
-            <a:spAutoFit/>
-          </a:bodyPr>
-          <a:lstStyle/>
+              <a:t>HIT140  ·  THREE-MINUTE BRIEFING</a:t>
+            </a:r>
+          </a:p>
+          <a:p>
+            <a:pPr algn="l">
+              <a:spcAft>
+                <a:spcPts val="800"/>
+              </a:spcAft>
+            </a:pPr>
+            <a:r>
+              <a:rPr sz="5200" b="0" i="1">
+                <a:solidFill>
+                  <a:srgbClr val="EFE6D3"/>
+                </a:solidFill>
+                <a:latin typeface="Georgia"/>
+              </a:rPr>
+              <a:t>World Cup 2026</a:t>
+            </a:r>
+          </a:p>
+          <a:p>
+            <a:pPr algn="l">
+              <a:spcAft>
+                <a:spcPts val="2200"/>
+              </a:spcAft>
+            </a:pPr>
+            <a:r>
+              <a:rPr sz="2200" b="0" i="1">
+                <a:solidFill>
+                  <a:srgbClr val="D9A544"/>
+                </a:solidFill>
+                <a:latin typeface="Georgia"/>
+              </a:rPr>
+              <a:t>What we asked, how we tested it, and what held up</a:t>
+            </a:r>
+          </a:p>
+          <a:p>
+            <a:pPr algn="l">
+              <a:spcAft>
+                <a:spcPts val="800"/>
+              </a:spcAft>
+            </a:pPr>
+            <a:r>
+              <a:rPr sz="1600" b="0" i="0">
+                <a:solidFill>
+                  <a:srgbClr val="B9B6AC"/>
+                </a:solidFill>
+                <a:latin typeface="Calibri"/>
+              </a:rPr>
+              <a:t>Four distinct statistical questions, each with a sample, a 95% confidence interval, and a t-test.</a:t>
+            </a:r>
+          </a:p>
+          <a:p>
+            <a:pPr algn="l">
+              <a:spcAft>
+                <a:spcPts val="800"/>
+              </a:spcAft>
+            </a:pPr>
+            <a:r>
+              <a:rPr sz="1600" b="0" i="0">
+                <a:solidFill>
+                  <a:srgbClr val="B9B6AC"/>
+                </a:solidFill>
+                <a:latin typeface="Calibri"/>
+              </a:rPr>
+              <a:t>Two linear models using only information available before kickoff.</a:t>
+            </a:r>
+          </a:p>
           <a:p>
             <a:pPr algn="l">
               <a:spcAft>
@@ -4059,84 +4290,13 @@
               </a:spcAft>
             </a:pPr>
             <a:r>
-              <a:rPr sz="5400" b="0" i="1">
-                <a:solidFill>
-                  <a:srgbClr val="EFE6D3"/>
-                </a:solidFill>
-                <a:latin typeface="Georgia"/>
-              </a:rPr>
-              <a:t>World Cup 2026</a:t>
-            </a:r>
-          </a:p>
-          <a:p>
-            <a:pPr algn="l">
-              <a:spcAft>
-                <a:spcPts val="400"/>
-              </a:spcAft>
-            </a:pPr>
-            <a:r>
-              <a:rPr sz="2800" b="0" i="1">
-                <a:solidFill>
-                  <a:srgbClr val="D9A544"/>
-                </a:solidFill>
-                <a:latin typeface="Georgia"/>
-              </a:rPr>
-              <a:t>What the numbers actually said</a:t>
-            </a:r>
-          </a:p>
-        </p:txBody>
-      </p:sp>
-      <p:sp>
-        <p:nvSpPr>
-          <p:cNvPr id="7" name="TextBox 6"/>
-          <p:cNvSpPr txBox="1"/>
-          <p:nvPr/>
-        </p:nvSpPr>
-        <p:spPr>
-          <a:xfrm>
-            <a:off x="777240" y="4709160"/>
-            <a:ext cx="10424160" cy="1280160"/>
-          </a:xfrm>
-          <a:prstGeom prst="rect">
-            <a:avLst/>
-          </a:prstGeom>
-          <a:noFill/>
-        </p:spPr>
-        <p:txBody>
-          <a:bodyPr wrap="square">
-            <a:spAutoFit/>
-          </a:bodyPr>
-          <a:lstStyle/>
-          <a:p>
-            <a:pPr algn="l">
-              <a:spcAft>
-                <a:spcPts val="400"/>
-              </a:spcAft>
-            </a:pPr>
-            <a:r>
-              <a:rPr sz="1800" b="0" i="0">
+              <a:rPr sz="1500" b="0" i="0">
                 <a:solidFill>
                   <a:srgbClr val="B9B6AC"/>
                 </a:solidFill>
                 <a:latin typeface="Calibri"/>
               </a:rPr>
-              <a:t>Four statistical questions  ·  Two pre-match prediction models</a:t>
-            </a:r>
-          </a:p>
-          <a:p>
-            <a:pPr algn="l">
-              <a:spcAft>
-                <a:spcPts val="400"/>
-              </a:spcAft>
-            </a:pPr>
-            <a:r>
-              <a:rPr sz="1600" b="0" i="0">
-                <a:solidFill>
-                  <a:srgbClr val="B9B6AC"/>
-                </a:solidFill>
-                <a:latin typeface="Calibri"/>
-              </a:rPr>
-              <a:t>Spain 1–0 Argentina (AET)  ·  19 July 2026  ·  MetLife Stadium</a:t>
+              <a:t>Spain 1–0 Argentina after extra time  ·  19 July 2026  ·  MetLife Stadium</a:t>
             </a:r>
           </a:p>
         </p:txBody>
@@ -4253,8 +4413,8 @@
         </p:nvSpPr>
         <p:spPr>
           <a:xfrm>
-            <a:off x="640080" y="320040"/>
-            <a:ext cx="10972800" cy="822960"/>
+            <a:off x="502920" y="201168"/>
+            <a:ext cx="11155680" cy="868680"/>
           </a:xfrm>
           <a:prstGeom prst="rect">
             <a:avLst/>
@@ -4273,29 +4433,29 @@
               </a:spcAft>
             </a:pPr>
             <a:r>
-              <a:rPr sz="1300" b="1" i="0">
+              <a:rPr sz="1200" b="1" i="0">
                 <a:solidFill>
                   <a:srgbClr val="8C2F39"/>
                 </a:solidFill>
                 <a:latin typeface="Calibri"/>
               </a:rPr>
-              <a:t>THE MATERIAL</a:t>
+              <a:t>HOW THE WORK WAS SET UP</a:t>
             </a:r>
           </a:p>
           <a:p>
             <a:pPr algn="l">
               <a:spcAft>
-                <a:spcPts val="400"/>
+                <a:spcPts val="0"/>
               </a:spcAft>
             </a:pPr>
             <a:r>
-              <a:rPr sz="2800" b="0" i="1">
+              <a:rPr sz="2400" b="0" i="1">
                 <a:solidFill>
                   <a:srgbClr val="171B22"/>
                 </a:solidFill>
                 <a:latin typeface="Georgia"/>
               </a:rPr>
-              <a:t>Real tournament data — not simulations</a:t>
+              <a:t>Real data, then the same inferential path every time</a:t>
             </a:r>
           </a:p>
         </p:txBody>
@@ -4308,8 +4468,8 @@
         </p:nvSpPr>
         <p:spPr>
           <a:xfrm>
-            <a:off x="640080" y="1554480"/>
-            <a:ext cx="2651760" cy="1965960"/>
+            <a:off x="502920" y="1280160"/>
+            <a:ext cx="2743200" cy="1691640"/>
           </a:xfrm>
           <a:prstGeom prst="rect">
             <a:avLst/>
@@ -4351,8 +4511,8 @@
         </p:nvSpPr>
         <p:spPr>
           <a:xfrm>
-            <a:off x="777240" y="1783080"/>
-            <a:ext cx="2377440" cy="1554480"/>
+            <a:off x="594360" y="1463040"/>
+            <a:ext cx="2560320" cy="1417320"/>
           </a:xfrm>
           <a:prstGeom prst="rect">
             <a:avLst/>
@@ -4371,7 +4531,7 @@
               </a:spcAft>
             </a:pPr>
             <a:r>
-              <a:rPr sz="3200" b="1" i="0">
+              <a:rPr sz="2800" b="1" i="0">
                 <a:solidFill>
                   <a:srgbClr val="D9A544"/>
                 </a:solidFill>
@@ -4383,7 +4543,7 @@
           <a:p>
             <a:pPr algn="ctr">
               <a:spcAft>
-                <a:spcPts val="400"/>
+                <a:spcPts val="0"/>
               </a:spcAft>
             </a:pPr>
             <a:r>
@@ -4393,7 +4553,7 @@
                 </a:solidFill>
                 <a:latin typeface="Calibri"/>
               </a:rPr>
-              <a:t>matches</a:t>
+              <a:t>official matches</a:t>
             </a:r>
           </a:p>
         </p:txBody>
@@ -4406,8 +4566,8 @@
         </p:nvSpPr>
         <p:spPr>
           <a:xfrm>
-            <a:off x="3474720" y="1554480"/>
-            <a:ext cx="2651760" cy="1965960"/>
+            <a:off x="3429000" y="1280160"/>
+            <a:ext cx="2743200" cy="1691640"/>
           </a:xfrm>
           <a:prstGeom prst="rect">
             <a:avLst/>
@@ -4449,8 +4609,8 @@
         </p:nvSpPr>
         <p:spPr>
           <a:xfrm>
-            <a:off x="3611880" y="1783080"/>
-            <a:ext cx="2377440" cy="1554480"/>
+            <a:off x="3520440" y="1463040"/>
+            <a:ext cx="2560320" cy="1417320"/>
           </a:xfrm>
           <a:prstGeom prst="rect">
             <a:avLst/>
@@ -4469,7 +4629,7 @@
               </a:spcAft>
             </a:pPr>
             <a:r>
-              <a:rPr sz="3200" b="1" i="0">
+              <a:rPr sz="2800" b="1" i="0">
                 <a:solidFill>
                   <a:srgbClr val="D9A544"/>
                 </a:solidFill>
@@ -4481,7 +4641,7 @@
           <a:p>
             <a:pPr algn="ctr">
               <a:spcAft>
-                <a:spcPts val="400"/>
+                <a:spcPts val="0"/>
               </a:spcAft>
             </a:pPr>
             <a:r>
@@ -4491,7 +4651,7 @@
                 </a:solidFill>
                 <a:latin typeface="Calibri"/>
               </a:rPr>
-              <a:t>teams</a:t>
+              <a:t>national teams</a:t>
             </a:r>
           </a:p>
         </p:txBody>
@@ -4504,8 +4664,8 @@
         </p:nvSpPr>
         <p:spPr>
           <a:xfrm>
-            <a:off x="6309360" y="1554480"/>
-            <a:ext cx="2651760" cy="1965960"/>
+            <a:off x="6355080" y="1280160"/>
+            <a:ext cx="2743200" cy="1691640"/>
           </a:xfrm>
           <a:prstGeom prst="rect">
             <a:avLst/>
@@ -4547,8 +4707,8 @@
         </p:nvSpPr>
         <p:spPr>
           <a:xfrm>
-            <a:off x="6446520" y="1783080"/>
-            <a:ext cx="2377440" cy="1554480"/>
+            <a:off x="6446520" y="1463040"/>
+            <a:ext cx="2560320" cy="1417320"/>
           </a:xfrm>
           <a:prstGeom prst="rect">
             <a:avLst/>
@@ -4567,7 +4727,7 @@
               </a:spcAft>
             </a:pPr>
             <a:r>
-              <a:rPr sz="3200" b="1" i="0">
+              <a:rPr sz="2800" b="1" i="0">
                 <a:solidFill>
                   <a:srgbClr val="D9A544"/>
                 </a:solidFill>
@@ -4579,7 +4739,7 @@
           <a:p>
             <a:pPr algn="ctr">
               <a:spcAft>
-                <a:spcPts val="400"/>
+                <a:spcPts val="0"/>
               </a:spcAft>
             </a:pPr>
             <a:r>
@@ -4602,8 +4762,8 @@
         </p:nvSpPr>
         <p:spPr>
           <a:xfrm>
-            <a:off x="9144000" y="1554480"/>
-            <a:ext cx="2651760" cy="1965960"/>
+            <a:off x="9281160" y="1280160"/>
+            <a:ext cx="2743200" cy="1691640"/>
           </a:xfrm>
           <a:prstGeom prst="rect">
             <a:avLst/>
@@ -4645,8 +4805,8 @@
         </p:nvSpPr>
         <p:spPr>
           <a:xfrm>
-            <a:off x="9281160" y="1783080"/>
-            <a:ext cx="2377440" cy="1554480"/>
+            <a:off x="9372600" y="1463040"/>
+            <a:ext cx="2560320" cy="1417320"/>
           </a:xfrm>
           <a:prstGeom prst="rect">
             <a:avLst/>
@@ -4665,7 +4825,7 @@
               </a:spcAft>
             </a:pPr>
             <a:r>
-              <a:rPr sz="3200" b="1" i="0">
+              <a:rPr sz="2800" b="1" i="0">
                 <a:solidFill>
                   <a:srgbClr val="D9A544"/>
                 </a:solidFill>
@@ -4677,7 +4837,7 @@
           <a:p>
             <a:pPr algn="ctr">
               <a:spcAft>
-                <a:spcPts val="400"/>
+                <a:spcPts val="0"/>
               </a:spcAft>
             </a:pPr>
             <a:r>
@@ -4687,7 +4847,7 @@
                 </a:solidFill>
                 <a:latin typeface="Calibri"/>
               </a:rPr>
-              <a:t>every test</a:t>
+              <a:t>every hypothesis test</a:t>
             </a:r>
           </a:p>
         </p:txBody>
@@ -4700,8 +4860,8 @@
         </p:nvSpPr>
         <p:spPr>
           <a:xfrm>
-            <a:off x="640080" y="3840480"/>
-            <a:ext cx="10972800" cy="2377440"/>
+            <a:off x="502920" y="3246120"/>
+            <a:ext cx="11155680" cy="3200400"/>
           </a:xfrm>
           <a:prstGeom prst="rect">
             <a:avLst/>
@@ -4716,39 +4876,39 @@
           <a:p>
             <a:pPr algn="l">
               <a:spcAft>
-                <a:spcPts val="1000"/>
+                <a:spcPts val="1200"/>
               </a:spcAft>
             </a:pPr>
             <a:r>
-              <a:rPr sz="1800" b="1" i="0">
+              <a:rPr sz="1600" b="0" i="0">
                 <a:solidFill>
                   <a:srgbClr val="171B22"/>
                 </a:solidFill>
                 <a:latin typeface="Calibri"/>
               </a:rPr>
-              <a:t>Each of the four tasks used the same pipeline</a:t>
+              <a:t>Each Objective 1 task had a different focal point — discipline, crowds, money, age — so we were not asking the same goals question four times.</a:t>
             </a:r>
           </a:p>
           <a:p>
             <a:pPr algn="l">
               <a:spcAft>
-                <a:spcPts val="1400"/>
+                <a:spcPts val="1200"/>
               </a:spcAft>
             </a:pPr>
             <a:r>
               <a:rPr sz="1600" b="0" i="0">
                 <a:solidFill>
-                  <a:srgbClr val="584F44"/>
+                  <a:srgbClr val="171B22"/>
                 </a:solidFill>
                 <a:latin typeface="Calibri"/>
               </a:rPr>
-              <a:t>Question  →  wrangle  →  sample  →  describe  →  95% confidence interval  →  t-test</a:t>
+              <a:t>Pipeline for every task:  formulate the question  →  wrangle  →  sample  →  describe  →  95% CI  →  t-test.</a:t>
             </a:r>
           </a:p>
           <a:p>
             <a:pPr algn="l">
               <a:spcAft>
-                <a:spcPts val="400"/>
+                <a:spcPts val="0"/>
               </a:spcAft>
             </a:pPr>
             <a:r>
@@ -4758,7 +4918,7 @@
                 </a:solidFill>
                 <a:latin typeface="Calibri"/>
               </a:rPr>
-              <a:t>Then two OLS models, 8 pre-match predictors each: goal difference (104 rows) and goals scored by a team (208 rows).</a:t>
+              <a:t>Objective 2 is different: predict the score from eight pre-match variables only. Ranking, squad value, age, host status, rest days, confederation, knockout flag. No shots, no possession, nothing from during the game.</a:t>
             </a:r>
           </a:p>
         </p:txBody>
@@ -4875,8 +5035,8 @@
         </p:nvSpPr>
         <p:spPr>
           <a:xfrm>
-            <a:off x="640080" y="292608"/>
-            <a:ext cx="10972800" cy="868680"/>
+            <a:off x="502920" y="201168"/>
+            <a:ext cx="11155680" cy="868680"/>
           </a:xfrm>
           <a:prstGeom prst="rect">
             <a:avLst/>
@@ -4895,15 +5055,54 @@
               </a:spcAft>
             </a:pPr>
             <a:r>
-              <a:rPr sz="1300" b="1" i="0">
+              <a:rPr sz="1200" b="1" i="0">
                 <a:solidFill>
                   <a:srgbClr val="8C2F39"/>
                 </a:solidFill>
                 <a:latin typeface="Calibri"/>
               </a:rPr>
-              <a:t>OBJECTIVE 1  ·  TWO NON-RESULTS</a:t>
-            </a:r>
-          </a:p>
+              <a:t>TASK 1  ·  PLAYER DISCIPLINE</a:t>
+            </a:r>
+          </a:p>
+          <a:p>
+            <a:pPr algn="l">
+              <a:spcAft>
+                <a:spcPts val="0"/>
+              </a:spcAft>
+            </a:pPr>
+            <a:r>
+              <a:rPr sz="2400" b="0" i="1">
+                <a:solidFill>
+                  <a:srgbClr val="171B22"/>
+                </a:solidFill>
+                <a:latin typeface="Georgia"/>
+              </a:rPr>
+              <a:t>Are midfielders booked more than defenders?</a:t>
+            </a:r>
+          </a:p>
+        </p:txBody>
+      </p:sp>
+      <p:sp>
+        <p:nvSpPr>
+          <p:cNvPr id="5" name="TextBox 4"/>
+          <p:cNvSpPr txBox="1"/>
+          <p:nvPr/>
+        </p:nvSpPr>
+        <p:spPr>
+          <a:xfrm>
+            <a:off x="502920" y="1143000"/>
+            <a:ext cx="5623560" cy="5303520"/>
+          </a:xfrm>
+          <a:prstGeom prst="rect">
+            <a:avLst/>
+          </a:prstGeom>
+          <a:noFill/>
+        </p:spPr>
+        <p:txBody>
+          <a:bodyPr wrap="square">
+            <a:spAutoFit/>
+          </a:bodyPr>
+          <a:lstStyle/>
           <a:p>
             <a:pPr algn="l">
               <a:spcAft>
@@ -4911,111 +5110,29 @@
               </a:spcAft>
             </a:pPr>
             <a:r>
-              <a:rPr sz="2600" b="0" i="1">
-                <a:solidFill>
-                  <a:srgbClr val="171B22"/>
-                </a:solidFill>
-                <a:latin typeface="Georgia"/>
+              <a:rPr sz="1300" b="1" i="0">
+                <a:solidFill>
+                  <a:srgbClr val="8C2F39"/>
+                </a:solidFill>
+                <a:latin typeface="Calibri"/>
               </a:rPr>
-              <a:t>Some football stories did not survive the test</a:t>
-            </a:r>
-          </a:p>
-        </p:txBody>
-      </p:sp>
-      <p:sp>
-        <p:nvSpPr>
-          <p:cNvPr id="5" name="Rectangle 4"/>
-          <p:cNvSpPr/>
-          <p:nvPr/>
-        </p:nvSpPr>
-        <p:spPr>
-          <a:xfrm>
-            <a:off x="640080" y="1417320"/>
-            <a:ext cx="5349240" cy="4846320"/>
-          </a:xfrm>
-          <a:prstGeom prst="rect">
-            <a:avLst/>
-          </a:prstGeom>
-          <a:solidFill>
-            <a:srgbClr val="171B22"/>
-          </a:solidFill>
-          <a:ln>
-            <a:noFill/>
-          </a:ln>
-        </p:spPr>
-        <p:style>
-          <a:lnRef idx="1">
-            <a:schemeClr val="accent1"/>
-          </a:lnRef>
-          <a:fillRef idx="3">
-            <a:schemeClr val="accent1"/>
-          </a:fillRef>
-          <a:effectRef idx="2">
-            <a:schemeClr val="accent1"/>
-          </a:effectRef>
-          <a:fontRef idx="minor">
-            <a:schemeClr val="lt1"/>
-          </a:fontRef>
-        </p:style>
-        <p:txBody>
-          <a:bodyPr rtlCol="0" anchor="ctr"/>
-          <a:lstStyle/>
-          <a:p>
-            <a:pPr algn="ctr"/>
-          </a:p>
-        </p:txBody>
-      </p:sp>
-      <p:sp>
-        <p:nvSpPr>
-          <p:cNvPr id="6" name="TextBox 5"/>
-          <p:cNvSpPr txBox="1"/>
-          <p:nvPr/>
-        </p:nvSpPr>
-        <p:spPr>
-          <a:xfrm>
-            <a:off x="868680" y="1645920"/>
-            <a:ext cx="4892040" cy="4389120"/>
-          </a:xfrm>
-          <a:prstGeom prst="rect">
-            <a:avLst/>
-          </a:prstGeom>
-          <a:noFill/>
-        </p:spPr>
-        <p:txBody>
-          <a:bodyPr wrap="square">
-            <a:spAutoFit/>
-          </a:bodyPr>
-          <a:lstStyle/>
+              <a:t>The story people tell</a:t>
+            </a:r>
+          </a:p>
           <a:p>
             <a:pPr algn="l">
               <a:spcAft>
-                <a:spcPts val="800"/>
+                <a:spcPts val="1200"/>
               </a:spcAft>
             </a:pPr>
             <a:r>
-              <a:rPr sz="1300" b="1" i="0">
-                <a:solidFill>
-                  <a:srgbClr val="D9A544"/>
+              <a:rPr sz="1500" b="0" i="0">
+                <a:solidFill>
+                  <a:srgbClr val="171B22"/>
                 </a:solidFill>
                 <a:latin typeface="Calibri"/>
               </a:rPr>
-              <a:t>DISCIPLINE</a:t>
-            </a:r>
-          </a:p>
-          <a:p>
-            <a:pPr algn="l">
-              <a:spcAft>
-                <a:spcPts val="1600"/>
-              </a:spcAft>
-            </a:pPr>
-            <a:r>
-              <a:rPr sz="1800" b="0" i="1">
-                <a:solidFill>
-                  <a:srgbClr val="EFE6D3"/>
-                </a:solidFill>
-                <a:latin typeface="Georgia"/>
-              </a:rPr>
-              <a:t>Are midfielders booked more than defenders?</a:t>
+              <a:t>Midfielders fight for the ball in the middle of the pitch, so they should pick up more yellow cards.</a:t>
             </a:r>
           </a:p>
           <a:p>
@@ -5025,29 +5142,13 @@
               </a:spcAft>
             </a:pPr>
             <a:r>
-              <a:rPr sz="3200" b="1" i="0">
-                <a:solidFill>
-                  <a:srgbClr val="FFFFFF"/>
-                </a:solidFill>
-                <a:latin typeface="Georgia"/>
-              </a:rPr>
-              <a:t>0.10  vs  0.13</a:t>
-            </a:r>
-          </a:p>
-          <a:p>
-            <a:pPr algn="l">
-              <a:spcAft>
-                <a:spcPts val="1600"/>
-              </a:spcAft>
-            </a:pPr>
-            <a:r>
-              <a:rPr sz="1400" b="0" i="0">
-                <a:solidFill>
-                  <a:srgbClr val="B9B6AC"/>
+              <a:rPr sz="1300" b="1" i="0">
+                <a:solidFill>
+                  <a:srgbClr val="8C2F39"/>
                 </a:solidFill>
                 <a:latin typeface="Calibri"/>
               </a:rPr>
-              <a:t>yellow cards per appearance</a:t>
+              <a:t>How we tested it</a:t>
             </a:r>
           </a:p>
           <a:p>
@@ -5057,13 +5158,13 @@
               </a:spcAft>
             </a:pPr>
             <a:r>
-              <a:rPr sz="1600" b="1" i="0">
-                <a:solidFill>
-                  <a:srgbClr val="D9A544"/>
+              <a:rPr sz="1500" b="0" i="0">
+                <a:solidFill>
+                  <a:srgbClr val="171B22"/>
                 </a:solidFill>
                 <a:latin typeface="Calibri"/>
               </a:rPr>
-              <a:t>p = 0.45   ·   fail to reject H₀</a:t>
+              <a:t>Only players with at least one appearance. Outcome is cards per appearance, so a seven-match finalist is compared fairly with a one-match substitute. Simple random sample of 45 midfielders and 45 defenders.</a:t>
             </a:r>
           </a:p>
           <a:p>
@@ -5073,111 +5174,29 @@
               </a:spcAft>
             </a:pPr>
             <a:r>
-              <a:rPr sz="1500" b="0" i="0">
-                <a:solidFill>
-                  <a:srgbClr val="B9B6AC"/>
+              <a:rPr sz="1300" b="1" i="0">
+                <a:solidFill>
+                  <a:srgbClr val="8C2F39"/>
                 </a:solidFill>
                 <a:latin typeface="Calibri"/>
               </a:rPr>
-              <a:t>The “midfield battle” is not dirtier. Difference is sampling noise (Cohen’s d = −0.16).</a:t>
-            </a:r>
-          </a:p>
-        </p:txBody>
-      </p:sp>
-      <p:sp>
-        <p:nvSpPr>
-          <p:cNvPr id="7" name="Rectangle 6"/>
-          <p:cNvSpPr/>
-          <p:nvPr/>
-        </p:nvSpPr>
-        <p:spPr>
-          <a:xfrm>
-            <a:off x="6217920" y="1417320"/>
-            <a:ext cx="5349240" cy="4846320"/>
-          </a:xfrm>
-          <a:prstGeom prst="rect">
-            <a:avLst/>
-          </a:prstGeom>
-          <a:solidFill>
-            <a:srgbClr val="24402C"/>
-          </a:solidFill>
-          <a:ln>
-            <a:noFill/>
-          </a:ln>
-        </p:spPr>
-        <p:style>
-          <a:lnRef idx="1">
-            <a:schemeClr val="accent1"/>
-          </a:lnRef>
-          <a:fillRef idx="3">
-            <a:schemeClr val="accent1"/>
-          </a:fillRef>
-          <a:effectRef idx="2">
-            <a:schemeClr val="accent1"/>
-          </a:effectRef>
-          <a:fontRef idx="minor">
-            <a:schemeClr val="lt1"/>
-          </a:fontRef>
-        </p:style>
-        <p:txBody>
-          <a:bodyPr rtlCol="0" anchor="ctr"/>
-          <a:lstStyle/>
-          <a:p>
-            <a:pPr algn="ctr"/>
-          </a:p>
-        </p:txBody>
-      </p:sp>
-      <p:sp>
-        <p:nvSpPr>
-          <p:cNvPr id="8" name="TextBox 7"/>
-          <p:cNvSpPr txBox="1"/>
-          <p:nvPr/>
-        </p:nvSpPr>
-        <p:spPr>
-          <a:xfrm>
-            <a:off x="6446520" y="1645920"/>
-            <a:ext cx="4892040" cy="4389120"/>
-          </a:xfrm>
-          <a:prstGeom prst="rect">
-            <a:avLst/>
-          </a:prstGeom>
-          <a:noFill/>
-        </p:spPr>
-        <p:txBody>
-          <a:bodyPr wrap="square">
-            <a:spAutoFit/>
-          </a:bodyPr>
-          <a:lstStyle/>
+              <a:t>What the chart shows</a:t>
+            </a:r>
+          </a:p>
           <a:p>
             <a:pPr algn="l">
               <a:spcAft>
-                <a:spcPts val="800"/>
+                <a:spcPts val="1200"/>
               </a:spcAft>
             </a:pPr>
             <a:r>
-              <a:rPr sz="1300" b="1" i="0">
-                <a:solidFill>
-                  <a:srgbClr val="D9A544"/>
+              <a:rPr sz="1500" b="0" i="0">
+                <a:solidFill>
+                  <a:srgbClr val="171B22"/>
                 </a:solidFill>
                 <a:latin typeface="Calibri"/>
               </a:rPr>
-              <a:t>ATTENDANCE</a:t>
-            </a:r>
-          </a:p>
-          <a:p>
-            <a:pPr algn="l">
-              <a:spcAft>
-                <a:spcPts val="1600"/>
-              </a:spcAft>
-            </a:pPr>
-            <a:r>
-              <a:rPr sz="1800" b="0" i="1">
-                <a:solidFill>
-                  <a:srgbClr val="EFE6D3"/>
-                </a:solidFill>
-                <a:latin typeface="Georgia"/>
-              </a:rPr>
-              <a:t>Did knockout games draw bigger crowds?</a:t>
+              <a:t>Both groups pile up at zero. Means: 0.10 vs 0.13. 95% CI for midfielders (0.04, 0.16).</a:t>
             </a:r>
           </a:p>
           <a:p>
@@ -5187,65 +5206,57 @@
               </a:spcAft>
             </a:pPr>
             <a:r>
-              <a:rPr sz="3200" b="1" i="0">
-                <a:solidFill>
-                  <a:srgbClr val="FFFFFF"/>
-                </a:solidFill>
-                <a:latin typeface="Georgia"/>
+              <a:rPr sz="1300" b="1" i="0">
+                <a:solidFill>
+                  <a:srgbClr val="8C2F39"/>
+                </a:solidFill>
+                <a:latin typeface="Calibri"/>
               </a:rPr>
-              <a:t>67.7k  vs  65.7k</a:t>
+              <a:t>Decision</a:t>
             </a:r>
           </a:p>
           <a:p>
             <a:pPr algn="l">
               <a:spcAft>
-                <a:spcPts val="1600"/>
+                <a:spcPts val="0"/>
               </a:spcAft>
             </a:pPr>
             <a:r>
-              <a:rPr sz="1400" b="0" i="0">
-                <a:solidFill>
-                  <a:srgbClr val="B9B6AC"/>
+              <a:rPr sz="1600" b="1" i="0">
+                <a:solidFill>
+                  <a:srgbClr val="171B22"/>
                 </a:solidFill>
                 <a:latin typeface="Calibri"/>
               </a:rPr>
-              <a:t>knockout vs group-stage mean</a:t>
-            </a:r>
-          </a:p>
-          <a:p>
-            <a:pPr algn="l">
-              <a:spcAft>
-                <a:spcPts val="1200"/>
-              </a:spcAft>
-            </a:pPr>
-            <a:r>
-              <a:rPr sz="1600" b="1" i="0">
-                <a:solidFill>
-                  <a:srgbClr val="D9A544"/>
-                </a:solidFill>
-                <a:latin typeface="Calibri"/>
-              </a:rPr>
-              <a:t>p = 0.38   ·   fail to reject H₀</a:t>
-            </a:r>
-          </a:p>
-          <a:p>
-            <a:pPr algn="l">
-              <a:spcAft>
-                <a:spcPts val="400"/>
-              </a:spcAft>
-            </a:pPr>
-            <a:r>
-              <a:rPr sz="1500" b="0" i="0">
-                <a:solidFill>
-                  <a:srgbClr val="B9B6AC"/>
-                </a:solidFill>
-                <a:latin typeface="Calibri"/>
-              </a:rPr>
-              <a:t>The 48-team format filled stadiums from match 1. Crowds did not wait for the knockouts.</a:t>
-            </a:r>
-          </a:p>
-        </p:txBody>
-      </p:sp>
+              <a:t>t-test p = 0.45. Fail to reject H₀. The “dirty midfield” is not supported.</a:t>
+            </a:r>
+          </a:p>
+        </p:txBody>
+      </p:sp>
+      <p:pic>
+        <p:nvPicPr>
+          <p:cNvPr id="6" name="Picture 5" descr="task1_discipline.png"/>
+          <p:cNvPicPr>
+            <a:picLocks noChangeAspect="1"/>
+          </p:cNvPicPr>
+          <p:nvPr/>
+        </p:nvPicPr>
+        <p:blipFill>
+          <a:blip r:embed="rId2"/>
+          <a:stretch>
+            <a:fillRect/>
+          </a:stretch>
+        </p:blipFill>
+        <p:spPr>
+          <a:xfrm>
+            <a:off x="6263640" y="1234440"/>
+            <a:ext cx="5440680" cy="2138632"/>
+          </a:xfrm>
+          <a:prstGeom prst="rect">
+            <a:avLst/>
+          </a:prstGeom>
+        </p:spPr>
+      </p:pic>
     </p:spTree>
   </p:cSld>
   <p:clrMapOvr>
@@ -5358,8 +5369,8 @@
         </p:nvSpPr>
         <p:spPr>
           <a:xfrm>
-            <a:off x="640080" y="292608"/>
-            <a:ext cx="10972800" cy="868680"/>
+            <a:off x="502920" y="201168"/>
+            <a:ext cx="11155680" cy="868680"/>
           </a:xfrm>
           <a:prstGeom prst="rect">
             <a:avLst/>
@@ -5378,15 +5389,54 @@
               </a:spcAft>
             </a:pPr>
             <a:r>
-              <a:rPr sz="1300" b="1" i="0">
+              <a:rPr sz="1200" b="1" i="0">
                 <a:solidFill>
                   <a:srgbClr val="8C2F39"/>
                 </a:solidFill>
                 <a:latin typeface="Calibri"/>
               </a:rPr>
-              <a:t>OBJECTIVE 1  ·  TWO CLEAR GAPS</a:t>
-            </a:r>
-          </a:p>
+              <a:t>TASK 2  ·  MATCH-DAY ATTENDANCE</a:t>
+            </a:r>
+          </a:p>
+          <a:p>
+            <a:pPr algn="l">
+              <a:spcAft>
+                <a:spcPts val="0"/>
+              </a:spcAft>
+            </a:pPr>
+            <a:r>
+              <a:rPr sz="2400" b="0" i="1">
+                <a:solidFill>
+                  <a:srgbClr val="171B22"/>
+                </a:solidFill>
+                <a:latin typeface="Georgia"/>
+              </a:rPr>
+              <a:t>Did knockout games draw bigger crowds?</a:t>
+            </a:r>
+          </a:p>
+        </p:txBody>
+      </p:sp>
+      <p:sp>
+        <p:nvSpPr>
+          <p:cNvPr id="5" name="TextBox 4"/>
+          <p:cNvSpPr txBox="1"/>
+          <p:nvPr/>
+        </p:nvSpPr>
+        <p:spPr>
+          <a:xfrm>
+            <a:off x="502920" y="1143000"/>
+            <a:ext cx="5623560" cy="5303520"/>
+          </a:xfrm>
+          <a:prstGeom prst="rect">
+            <a:avLst/>
+          </a:prstGeom>
+          <a:noFill/>
+        </p:spPr>
+        <p:txBody>
+          <a:bodyPr wrap="square">
+            <a:spAutoFit/>
+          </a:bodyPr>
+          <a:lstStyle/>
           <a:p>
             <a:pPr algn="l">
               <a:spcAft>
@@ -5394,111 +5444,29 @@
               </a:spcAft>
             </a:pPr>
             <a:r>
-              <a:rPr sz="2600" b="0" i="1">
-                <a:solidFill>
-                  <a:srgbClr val="171B22"/>
-                </a:solidFill>
-                <a:latin typeface="Georgia"/>
+              <a:rPr sz="1300" b="1" i="0">
+                <a:solidFill>
+                  <a:srgbClr val="8C2F39"/>
+                </a:solidFill>
+                <a:latin typeface="Calibri"/>
               </a:rPr>
-              <a:t>Money and age did show up</a:t>
-            </a:r>
-          </a:p>
-        </p:txBody>
-      </p:sp>
-      <p:sp>
-        <p:nvSpPr>
-          <p:cNvPr id="5" name="Rectangle 4"/>
-          <p:cNvSpPr/>
-          <p:nvPr/>
-        </p:nvSpPr>
-        <p:spPr>
-          <a:xfrm>
-            <a:off x="640080" y="1417320"/>
-            <a:ext cx="5349240" cy="4846320"/>
-          </a:xfrm>
-          <a:prstGeom prst="rect">
-            <a:avLst/>
-          </a:prstGeom>
-          <a:solidFill>
-            <a:srgbClr val="8C2F39"/>
-          </a:solidFill>
-          <a:ln>
-            <a:noFill/>
-          </a:ln>
-        </p:spPr>
-        <p:style>
-          <a:lnRef idx="1">
-            <a:schemeClr val="accent1"/>
-          </a:lnRef>
-          <a:fillRef idx="3">
-            <a:schemeClr val="accent1"/>
-          </a:fillRef>
-          <a:effectRef idx="2">
-            <a:schemeClr val="accent1"/>
-          </a:effectRef>
-          <a:fontRef idx="minor">
-            <a:schemeClr val="lt1"/>
-          </a:fontRef>
-        </p:style>
-        <p:txBody>
-          <a:bodyPr rtlCol="0" anchor="ctr"/>
-          <a:lstStyle/>
-          <a:p>
-            <a:pPr algn="ctr"/>
-          </a:p>
-        </p:txBody>
-      </p:sp>
-      <p:sp>
-        <p:nvSpPr>
-          <p:cNvPr id="6" name="TextBox 5"/>
-          <p:cNvSpPr txBox="1"/>
-          <p:nvPr/>
-        </p:nvSpPr>
-        <p:spPr>
-          <a:xfrm>
-            <a:off x="868680" y="1645920"/>
-            <a:ext cx="4892040" cy="4389120"/>
-          </a:xfrm>
-          <a:prstGeom prst="rect">
-            <a:avLst/>
-          </a:prstGeom>
-          <a:noFill/>
-        </p:spPr>
-        <p:txBody>
-          <a:bodyPr wrap="square">
-            <a:spAutoFit/>
-          </a:bodyPr>
-          <a:lstStyle/>
+              <a:t>The story people tell</a:t>
+            </a:r>
+          </a:p>
           <a:p>
             <a:pPr algn="l">
               <a:spcAft>
-                <a:spcPts val="800"/>
+                <a:spcPts val="1200"/>
               </a:spcAft>
             </a:pPr>
             <a:r>
-              <a:rPr sz="1300" b="1" i="0">
-                <a:solidFill>
-                  <a:srgbClr val="D9A544"/>
+              <a:rPr sz="1500" b="0" i="0">
+                <a:solidFill>
+                  <a:srgbClr val="171B22"/>
                 </a:solidFill>
                 <a:latin typeface="Calibri"/>
               </a:rPr>
-              <a:t>SQUAD VALUE</a:t>
-            </a:r>
-          </a:p>
-          <a:p>
-            <a:pPr algn="l">
-              <a:spcAft>
-                <a:spcPts val="1600"/>
-              </a:spcAft>
-            </a:pPr>
-            <a:r>
-              <a:rPr sz="1800" b="0" i="1">
-                <a:solidFill>
-                  <a:srgbClr val="EFE6D3"/>
-                </a:solidFill>
-                <a:latin typeface="Georgia"/>
-              </a:rPr>
-              <a:t>Are UEFA squads worth more?</a:t>
+              <a:t>A 48-team group stage is spread across weekday slots, so knockouts should look fuller.</a:t>
             </a:r>
           </a:p>
           <a:p>
@@ -5508,29 +5476,13 @@
               </a:spcAft>
             </a:pPr>
             <a:r>
-              <a:rPr sz="4400" b="1" i="0">
-                <a:solidFill>
-                  <a:srgbClr val="FFFFFF"/>
-                </a:solidFill>
-                <a:latin typeface="Georgia"/>
-              </a:rPr>
-              <a:t>2.6×</a:t>
-            </a:r>
-          </a:p>
-          <a:p>
-            <a:pPr algn="l">
-              <a:spcAft>
-                <a:spcPts val="1600"/>
-              </a:spcAft>
-            </a:pPr>
-            <a:r>
-              <a:rPr sz="1400" b="0" i="0">
-                <a:solidFill>
-                  <a:srgbClr val="EFE6D3"/>
+              <a:rPr sz="1300" b="1" i="0">
+                <a:solidFill>
+                  <a:srgbClr val="8C2F39"/>
                 </a:solidFill>
                 <a:latin typeface="Calibri"/>
               </a:rPr>
-              <a:t>€670m UEFA  vs  €257m rest of world</a:t>
+              <a:t>How we tested it</a:t>
             </a:r>
           </a:p>
           <a:p>
@@ -5540,13 +5492,13 @@
               </a:spcAft>
             </a:pPr>
             <a:r>
-              <a:rPr sz="1600" b="1" i="0">
-                <a:solidFill>
-                  <a:srgbClr val="D9A544"/>
+              <a:rPr sz="1500" b="0" i="0">
+                <a:solidFill>
+                  <a:srgbClr val="171B22"/>
                 </a:solidFill>
                 <a:latin typeface="Calibri"/>
               </a:rPr>
-              <a:t>p = 0.004   ·   reject H₀   ·   d = 1.08</a:t>
+              <a:t>All 104 matches have official attendance. Stratified sample: every knockout match (32) plus 32 random group matches, so the two groups are the same size.</a:t>
             </a:r>
           </a:p>
           <a:p>
@@ -5556,111 +5508,29 @@
               </a:spcAft>
             </a:pPr>
             <a:r>
-              <a:rPr sz="1500" b="0" i="0">
-                <a:solidFill>
-                  <a:srgbClr val="EFE6D3"/>
+              <a:rPr sz="1300" b="1" i="0">
+                <a:solidFill>
+                  <a:srgbClr val="8C2F39"/>
                 </a:solidFill>
                 <a:latin typeface="Calibri"/>
               </a:rPr>
-              <a:t>Europe’s club market shows up in national-team valuations. Large effect.</a:t>
-            </a:r>
-          </a:p>
-        </p:txBody>
-      </p:sp>
-      <p:sp>
-        <p:nvSpPr>
-          <p:cNvPr id="7" name="Rectangle 6"/>
-          <p:cNvSpPr/>
-          <p:nvPr/>
-        </p:nvSpPr>
-        <p:spPr>
-          <a:xfrm>
-            <a:off x="6217920" y="1417320"/>
-            <a:ext cx="5349240" cy="4846320"/>
-          </a:xfrm>
-          <a:prstGeom prst="rect">
-            <a:avLst/>
-          </a:prstGeom>
-          <a:solidFill>
-            <a:srgbClr val="171B22"/>
-          </a:solidFill>
-          <a:ln>
-            <a:noFill/>
-          </a:ln>
-        </p:spPr>
-        <p:style>
-          <a:lnRef idx="1">
-            <a:schemeClr val="accent1"/>
-          </a:lnRef>
-          <a:fillRef idx="3">
-            <a:schemeClr val="accent1"/>
-          </a:fillRef>
-          <a:effectRef idx="2">
-            <a:schemeClr val="accent1"/>
-          </a:effectRef>
-          <a:fontRef idx="minor">
-            <a:schemeClr val="lt1"/>
-          </a:fontRef>
-        </p:style>
-        <p:txBody>
-          <a:bodyPr rtlCol="0" anchor="ctr"/>
-          <a:lstStyle/>
-          <a:p>
-            <a:pPr algn="ctr"/>
-          </a:p>
-        </p:txBody>
-      </p:sp>
-      <p:sp>
-        <p:nvSpPr>
-          <p:cNvPr id="8" name="TextBox 7"/>
-          <p:cNvSpPr txBox="1"/>
-          <p:nvPr/>
-        </p:nvSpPr>
-        <p:spPr>
-          <a:xfrm>
-            <a:off x="6446520" y="1645920"/>
-            <a:ext cx="4892040" cy="4389120"/>
-          </a:xfrm>
-          <a:prstGeom prst="rect">
-            <a:avLst/>
-          </a:prstGeom>
-          <a:noFill/>
-        </p:spPr>
-        <p:txBody>
-          <a:bodyPr wrap="square">
-            <a:spAutoFit/>
-          </a:bodyPr>
-          <a:lstStyle/>
+              <a:t>What the chart shows</a:t>
+            </a:r>
+          </a:p>
           <a:p>
             <a:pPr algn="l">
               <a:spcAft>
-                <a:spcPts val="800"/>
+                <a:spcPts val="1200"/>
               </a:spcAft>
             </a:pPr>
             <a:r>
-              <a:rPr sz="1300" b="1" i="0">
-                <a:solidFill>
-                  <a:srgbClr val="D9A544"/>
+              <a:rPr sz="1500" b="0" i="0">
+                <a:solidFill>
+                  <a:srgbClr val="171B22"/>
                 </a:solidFill>
                 <a:latin typeface="Calibri"/>
               </a:rPr>
-              <a:t>GOALKEEPER AGE</a:t>
-            </a:r>
-          </a:p>
-          <a:p>
-            <a:pPr algn="l">
-              <a:spcAft>
-                <a:spcPts val="1600"/>
-              </a:spcAft>
-            </a:pPr>
-            <a:r>
-              <a:rPr sz="1800" b="0" i="1">
-                <a:solidFill>
-                  <a:srgbClr val="EFE6D3"/>
-                </a:solidFill>
-                <a:latin typeface="Georgia"/>
-              </a:rPr>
-              <a:t>Do keepers last past the outfield “prime” of 27?</a:t>
+              <a:t>The boxes sit on top of each other. Means: 67,701 vs 65,747. Overall 95% CI about (64.5k, 68.9k).</a:t>
             </a:r>
           </a:p>
           <a:p>
@@ -5670,65 +5540,57 @@
               </a:spcAft>
             </a:pPr>
             <a:r>
-              <a:rPr sz="4400" b="1" i="0">
-                <a:solidFill>
-                  <a:srgbClr val="FFFFFF"/>
-                </a:solidFill>
-                <a:latin typeface="Georgia"/>
+              <a:rPr sz="1300" b="1" i="0">
+                <a:solidFill>
+                  <a:srgbClr val="8C2F39"/>
+                </a:solidFill>
+                <a:latin typeface="Calibri"/>
               </a:rPr>
-              <a:t>30.3 yrs</a:t>
+              <a:t>Decision</a:t>
             </a:r>
           </a:p>
           <a:p>
             <a:pPr algn="l">
               <a:spcAft>
-                <a:spcPts val="1600"/>
+                <a:spcPts val="0"/>
               </a:spcAft>
             </a:pPr>
             <a:r>
-              <a:rPr sz="1400" b="0" i="0">
-                <a:solidFill>
-                  <a:srgbClr val="B9B6AC"/>
+              <a:rPr sz="1600" b="1" i="0">
+                <a:solidFill>
+                  <a:srgbClr val="171B22"/>
                 </a:solidFill>
                 <a:latin typeface="Calibri"/>
               </a:rPr>
-              <a:t>vs 27-year benchmark  ·  outfield mean 26.7</a:t>
-            </a:r>
-          </a:p>
-          <a:p>
-            <a:pPr algn="l">
-              <a:spcAft>
-                <a:spcPts val="1200"/>
-              </a:spcAft>
-            </a:pPr>
-            <a:r>
-              <a:rPr sz="1600" b="1" i="0">
-                <a:solidFill>
-                  <a:srgbClr val="D9A544"/>
-                </a:solidFill>
-                <a:latin typeface="Calibri"/>
-              </a:rPr>
-              <a:t>p = 0.0001   ·   reject H₀   ·   d = 0.67</a:t>
-            </a:r>
-          </a:p>
-          <a:p>
-            <a:pPr algn="l">
-              <a:spcAft>
-                <a:spcPts val="400"/>
-              </a:spcAft>
-            </a:pPr>
-            <a:r>
-              <a:rPr sz="1500" b="0" i="0">
-                <a:solidFill>
-                  <a:srgbClr val="B9B6AC"/>
-                </a:solidFill>
-                <a:latin typeface="Calibri"/>
-              </a:rPr>
-              <a:t>Keepers are ~3.6 years older than outfield teammates. Longer shelf life is real.</a:t>
-            </a:r>
-          </a:p>
-        </p:txBody>
-      </p:sp>
+              <a:t>p = 0.38. Fail to reject H₀. Crowds were large from match one — they did not wait for the knockouts.</a:t>
+            </a:r>
+          </a:p>
+        </p:txBody>
+      </p:sp>
+      <p:pic>
+        <p:nvPicPr>
+          <p:cNvPr id="6" name="Picture 5" descr="task2_attendance.png"/>
+          <p:cNvPicPr>
+            <a:picLocks noChangeAspect="1"/>
+          </p:cNvPicPr>
+          <p:nvPr/>
+        </p:nvPicPr>
+        <p:blipFill>
+          <a:blip r:embed="rId2"/>
+          <a:stretch>
+            <a:fillRect/>
+          </a:stretch>
+        </p:blipFill>
+        <p:spPr>
+          <a:xfrm>
+            <a:off x="6263640" y="1234440"/>
+            <a:ext cx="5440680" cy="3098665"/>
+          </a:xfrm>
+          <a:prstGeom prst="rect">
+            <a:avLst/>
+          </a:prstGeom>
+        </p:spPr>
+      </p:pic>
     </p:spTree>
   </p:cSld>
   <p:clrMapOvr>
@@ -5841,8 +5703,8 @@
         </p:nvSpPr>
         <p:spPr>
           <a:xfrm>
-            <a:off x="640080" y="256032"/>
-            <a:ext cx="10972800" cy="868680"/>
+            <a:off x="502920" y="201168"/>
+            <a:ext cx="11155680" cy="868680"/>
           </a:xfrm>
           <a:prstGeom prst="rect">
             <a:avLst/>
@@ -5861,15 +5723,54 @@
               </a:spcAft>
             </a:pPr>
             <a:r>
-              <a:rPr sz="1300" b="1" i="0">
+              <a:rPr sz="1200" b="1" i="0">
                 <a:solidFill>
                   <a:srgbClr val="8C2F39"/>
                 </a:solidFill>
                 <a:latin typeface="Calibri"/>
               </a:rPr>
-              <a:t>OBJECTIVE 2  ·  BEFORE KICKOFF</a:t>
-            </a:r>
-          </a:p>
+              <a:t>TASK 3  ·  SQUAD MARKET VALUE</a:t>
+            </a:r>
+          </a:p>
+          <a:p>
+            <a:pPr algn="l">
+              <a:spcAft>
+                <a:spcPts val="0"/>
+              </a:spcAft>
+            </a:pPr>
+            <a:r>
+              <a:rPr sz="2400" b="0" i="1">
+                <a:solidFill>
+                  <a:srgbClr val="171B22"/>
+                </a:solidFill>
+                <a:latin typeface="Georgia"/>
+              </a:rPr>
+              <a:t>Do UEFA squads carry more value than the rest?</a:t>
+            </a:r>
+          </a:p>
+        </p:txBody>
+      </p:sp>
+      <p:sp>
+        <p:nvSpPr>
+          <p:cNvPr id="5" name="TextBox 4"/>
+          <p:cNvSpPr txBox="1"/>
+          <p:nvPr/>
+        </p:nvSpPr>
+        <p:spPr>
+          <a:xfrm>
+            <a:off x="502920" y="1143000"/>
+            <a:ext cx="5623560" cy="5303520"/>
+          </a:xfrm>
+          <a:prstGeom prst="rect">
+            <a:avLst/>
+          </a:prstGeom>
+          <a:noFill/>
+        </p:spPr>
+        <p:txBody>
+          <a:bodyPr wrap="square">
+            <a:spAutoFit/>
+          </a:bodyPr>
+          <a:lstStyle/>
           <a:p>
             <a:pPr algn="l">
               <a:spcAft>
@@ -5877,95 +5778,13 @@
               </a:spcAft>
             </a:pPr>
             <a:r>
-              <a:rPr sz="2600" b="0" i="1">
-                <a:solidFill>
-                  <a:srgbClr val="171B22"/>
-                </a:solidFill>
-                <a:latin typeface="Georgia"/>
-              </a:rPr>
-              <a:t>Rank and squad value predict the scoreline</a:t>
-            </a:r>
-          </a:p>
-        </p:txBody>
-      </p:sp>
-      <p:sp>
-        <p:nvSpPr>
-          <p:cNvPr id="5" name="Rectangle 4"/>
-          <p:cNvSpPr/>
-          <p:nvPr/>
-        </p:nvSpPr>
-        <p:spPr>
-          <a:xfrm>
-            <a:off x="640080" y="1325880"/>
-            <a:ext cx="5349240" cy="4983480"/>
-          </a:xfrm>
-          <a:prstGeom prst="rect">
-            <a:avLst/>
-          </a:prstGeom>
-          <a:solidFill>
-            <a:srgbClr val="171B22"/>
-          </a:solidFill>
-          <a:ln>
-            <a:noFill/>
-          </a:ln>
-        </p:spPr>
-        <p:style>
-          <a:lnRef idx="1">
-            <a:schemeClr val="accent1"/>
-          </a:lnRef>
-          <a:fillRef idx="3">
-            <a:schemeClr val="accent1"/>
-          </a:fillRef>
-          <a:effectRef idx="2">
-            <a:schemeClr val="accent1"/>
-          </a:effectRef>
-          <a:fontRef idx="minor">
-            <a:schemeClr val="lt1"/>
-          </a:fontRef>
-        </p:style>
-        <p:txBody>
-          <a:bodyPr rtlCol="0" anchor="ctr"/>
-          <a:lstStyle/>
-          <a:p>
-            <a:pPr algn="ctr"/>
-          </a:p>
-        </p:txBody>
-      </p:sp>
-      <p:sp>
-        <p:nvSpPr>
-          <p:cNvPr id="6" name="TextBox 5"/>
-          <p:cNvSpPr txBox="1"/>
-          <p:nvPr/>
-        </p:nvSpPr>
-        <p:spPr>
-          <a:xfrm>
-            <a:off x="868680" y="1508760"/>
-            <a:ext cx="4892040" cy="4617720"/>
-          </a:xfrm>
-          <a:prstGeom prst="rect">
-            <a:avLst/>
-          </a:prstGeom>
-          <a:noFill/>
-        </p:spPr>
-        <p:txBody>
-          <a:bodyPr wrap="square">
-            <a:spAutoFit/>
-          </a:bodyPr>
-          <a:lstStyle/>
-          <a:p>
-            <a:pPr algn="l">
-              <a:spcAft>
-                <a:spcPts val="800"/>
-              </a:spcAft>
-            </a:pPr>
-            <a:r>
               <a:rPr sz="1300" b="1" i="0">
                 <a:solidFill>
-                  <a:srgbClr val="D9A544"/>
+                  <a:srgbClr val="8C2F39"/>
                 </a:solidFill>
                 <a:latin typeface="Calibri"/>
               </a:rPr>
-              <a:t>MODEL 2.1  ·  104 MATCHES</a:t>
+              <a:t>The story people tell</a:t>
             </a:r>
           </a:p>
           <a:p>
@@ -5975,13 +5794,13 @@
               </a:spcAft>
             </a:pPr>
             <a:r>
-              <a:rPr sz="2200" b="0" i="1">
-                <a:solidFill>
-                  <a:srgbClr val="EFE6D3"/>
-                </a:solidFill>
-                <a:latin typeface="Georgia"/>
+              <a:rPr sz="1500" b="0" i="0">
+                <a:solidFill>
+                  <a:srgbClr val="171B22"/>
+                </a:solidFill>
+                <a:latin typeface="Calibri"/>
               </a:rPr>
-              <a:t>Goal difference</a:t>
+              <a:t>European national teams stock their World Cup squads from the richest club leagues, so they should be worth more.</a:t>
             </a:r>
           </a:p>
           <a:p>
@@ -5991,45 +5810,13 @@
               </a:spcAft>
             </a:pPr>
             <a:r>
-              <a:rPr sz="3600" b="1" i="0">
-                <a:solidFill>
-                  <a:srgbClr val="FFFFFF"/>
-                </a:solidFill>
-                <a:latin typeface="Georgia"/>
-              </a:rPr>
-              <a:t>R² = 0.49</a:t>
-            </a:r>
-          </a:p>
-          <a:p>
-            <a:pPr algn="l">
-              <a:spcAft>
-                <a:spcPts val="1600"/>
-              </a:spcAft>
-            </a:pPr>
-            <a:r>
-              <a:rPr sz="1400" b="0" i="0">
-                <a:solidFill>
-                  <a:srgbClr val="B9B6AC"/>
+              <a:rPr sz="1300" b="1" i="0">
+                <a:solidFill>
+                  <a:srgbClr val="8C2F39"/>
                 </a:solidFill>
                 <a:latin typeface="Calibri"/>
               </a:rPr>
-              <a:t>test R² 0.31   ·   RMSE 1.57 goals</a:t>
-            </a:r>
-          </a:p>
-          <a:p>
-            <a:pPr algn="l">
-              <a:spcAft>
-                <a:spcPts val="600"/>
-              </a:spcAft>
-            </a:pPr>
-            <a:r>
-              <a:rPr sz="1400" b="1" i="0">
-                <a:solidFill>
-                  <a:srgbClr val="D9A544"/>
-                </a:solidFill>
-                <a:latin typeface="Calibri"/>
-              </a:rPr>
-              <a:t>What mattered (p &lt; 0.05)</a:t>
+              <a:t>How we tested it</a:t>
             </a:r>
           </a:p>
           <a:p>
@@ -6039,13 +5826,13 @@
               </a:spcAft>
             </a:pPr>
             <a:r>
-              <a:rPr sz="1600" b="0" i="0">
-                <a:solidFill>
-                  <a:srgbClr val="EFE6D3"/>
+              <a:rPr sz="1500" b="0" i="0">
+                <a:solidFill>
+                  <a:srgbClr val="171B22"/>
                 </a:solidFill>
                 <a:latin typeface="Calibri"/>
               </a:rPr>
-              <a:t>FIFA rank gap  ·  squad-value gap</a:t>
+              <a:t>Transfermarkt value of each 26-man squad. Balanced sample of 14 UEFA teams and 14 from CONMEBOL, CONCACAF, CAF, AFC and OFC. One-sided test: UEFA higher.</a:t>
             </a:r>
           </a:p>
           <a:p>
@@ -6055,95 +5842,13 @@
               </a:spcAft>
             </a:pPr>
             <a:r>
-              <a:rPr sz="1400" b="0" i="0">
-                <a:solidFill>
-                  <a:srgbClr val="B9B6AC"/>
+              <a:rPr sz="1300" b="1" i="0">
+                <a:solidFill>
+                  <a:srgbClr val="8C2F39"/>
                 </a:solidFill>
                 <a:latin typeface="Calibri"/>
               </a:rPr>
-              <a:t>Host, rest, age, prior titles: not significant once rank and money are in the model.</a:t>
-            </a:r>
-          </a:p>
-        </p:txBody>
-      </p:sp>
-      <p:sp>
-        <p:nvSpPr>
-          <p:cNvPr id="7" name="Rectangle 6"/>
-          <p:cNvSpPr/>
-          <p:nvPr/>
-        </p:nvSpPr>
-        <p:spPr>
-          <a:xfrm>
-            <a:off x="6217920" y="1325880"/>
-            <a:ext cx="5349240" cy="4983480"/>
-          </a:xfrm>
-          <a:prstGeom prst="rect">
-            <a:avLst/>
-          </a:prstGeom>
-          <a:solidFill>
-            <a:srgbClr val="24402C"/>
-          </a:solidFill>
-          <a:ln>
-            <a:noFill/>
-          </a:ln>
-        </p:spPr>
-        <p:style>
-          <a:lnRef idx="1">
-            <a:schemeClr val="accent1"/>
-          </a:lnRef>
-          <a:fillRef idx="3">
-            <a:schemeClr val="accent1"/>
-          </a:fillRef>
-          <a:effectRef idx="2">
-            <a:schemeClr val="accent1"/>
-          </a:effectRef>
-          <a:fontRef idx="minor">
-            <a:schemeClr val="lt1"/>
-          </a:fontRef>
-        </p:style>
-        <p:txBody>
-          <a:bodyPr rtlCol="0" anchor="ctr"/>
-          <a:lstStyle/>
-          <a:p>
-            <a:pPr algn="ctr"/>
-          </a:p>
-        </p:txBody>
-      </p:sp>
-      <p:sp>
-        <p:nvSpPr>
-          <p:cNvPr id="8" name="TextBox 7"/>
-          <p:cNvSpPr txBox="1"/>
-          <p:nvPr/>
-        </p:nvSpPr>
-        <p:spPr>
-          <a:xfrm>
-            <a:off x="6446520" y="1508760"/>
-            <a:ext cx="4892040" cy="4617720"/>
-          </a:xfrm>
-          <a:prstGeom prst="rect">
-            <a:avLst/>
-          </a:prstGeom>
-          <a:noFill/>
-        </p:spPr>
-        <p:txBody>
-          <a:bodyPr wrap="square">
-            <a:spAutoFit/>
-          </a:bodyPr>
-          <a:lstStyle/>
-          <a:p>
-            <a:pPr algn="l">
-              <a:spcAft>
-                <a:spcPts val="800"/>
-              </a:spcAft>
-            </a:pPr>
-            <a:r>
-              <a:rPr sz="1300" b="1" i="0">
-                <a:solidFill>
-                  <a:srgbClr val="D9A544"/>
-                </a:solidFill>
-                <a:latin typeface="Calibri"/>
-              </a:rPr>
-              <a:t>MODEL 2.2  ·  208 TEAM-MATCHES</a:t>
+              <a:t>What the chart shows</a:t>
             </a:r>
           </a:p>
           <a:p>
@@ -6153,13 +5858,13 @@
               </a:spcAft>
             </a:pPr>
             <a:r>
-              <a:rPr sz="2200" b="0" i="1">
-                <a:solidFill>
-                  <a:srgbClr val="EFE6D3"/>
-                </a:solidFill>
-                <a:latin typeface="Georgia"/>
+              <a:rPr sz="1500" b="0" i="0">
+                <a:solidFill>
+                  <a:srgbClr val="171B22"/>
+                </a:solidFill>
+                <a:latin typeface="Calibri"/>
               </a:rPr>
-              <a:t>Goals scored by a team</a:t>
+              <a:t>UEFA median and mean sit far above the rest: €670m vs €257m — about 2.6 times.</a:t>
             </a:r>
           </a:p>
           <a:p>
@@ -6169,81 +5874,57 @@
               </a:spcAft>
             </a:pPr>
             <a:r>
-              <a:rPr sz="3600" b="1" i="0">
-                <a:solidFill>
-                  <a:srgbClr val="FFFFFF"/>
-                </a:solidFill>
-                <a:latin typeface="Georgia"/>
+              <a:rPr sz="1300" b="1" i="0">
+                <a:solidFill>
+                  <a:srgbClr val="8C2F39"/>
+                </a:solidFill>
+                <a:latin typeface="Calibri"/>
               </a:rPr>
-              <a:t>R² = 0.29</a:t>
+              <a:t>Decision</a:t>
             </a:r>
           </a:p>
           <a:p>
             <a:pPr algn="l">
               <a:spcAft>
-                <a:spcPts val="1600"/>
+                <a:spcPts val="0"/>
               </a:spcAft>
             </a:pPr>
             <a:r>
-              <a:rPr sz="1400" b="0" i="0">
-                <a:solidFill>
-                  <a:srgbClr val="B9B6AC"/>
+              <a:rPr sz="1600" b="1" i="0">
+                <a:solidFill>
+                  <a:srgbClr val="171B22"/>
                 </a:solidFill>
                 <a:latin typeface="Calibri"/>
               </a:rPr>
-              <a:t>test R² 0.22   ·   RMSE 1.23 goals</a:t>
-            </a:r>
-          </a:p>
-          <a:p>
-            <a:pPr algn="l">
-              <a:spcAft>
-                <a:spcPts val="600"/>
-              </a:spcAft>
-            </a:pPr>
-            <a:r>
-              <a:rPr sz="1400" b="1" i="0">
-                <a:solidFill>
-                  <a:srgbClr val="D9A544"/>
-                </a:solidFill>
-                <a:latin typeface="Calibri"/>
-              </a:rPr>
-              <a:t>What mattered (p &lt; 0.05)</a:t>
-            </a:r>
-          </a:p>
-          <a:p>
-            <a:pPr algn="l">
-              <a:spcAft>
-                <a:spcPts val="1200"/>
-              </a:spcAft>
-            </a:pPr>
-            <a:r>
-              <a:rPr sz="1600" b="0" i="0">
-                <a:solidFill>
-                  <a:srgbClr val="EFE6D3"/>
-                </a:solidFill>
-                <a:latin typeface="Calibri"/>
-              </a:rPr>
-              <a:t>Opponent’s rank  ·  own squad value</a:t>
-            </a:r>
-          </a:p>
-          <a:p>
-            <a:pPr algn="l">
-              <a:spcAft>
-                <a:spcPts val="400"/>
-              </a:spcAft>
-            </a:pPr>
-            <a:r>
-              <a:rPr sz="1400" b="0" i="0">
-                <a:solidFill>
-                  <a:srgbClr val="B9B6AC"/>
-                </a:solidFill>
-                <a:latin typeface="Calibri"/>
-              </a:rPr>
-              <a:t>Noisier target — one team’s goal tally is harder than the relative difference.</a:t>
-            </a:r>
-          </a:p>
-        </p:txBody>
-      </p:sp>
+              <a:t>p = 0.004. Reject H₀. Large effect (d = 1.08). Europe’s club market shows up at national-team level.</a:t>
+            </a:r>
+          </a:p>
+        </p:txBody>
+      </p:sp>
+      <p:pic>
+        <p:nvPicPr>
+          <p:cNvPr id="6" name="Picture 5" descr="task3_value.png"/>
+          <p:cNvPicPr>
+            <a:picLocks noChangeAspect="1"/>
+          </p:cNvPicPr>
+          <p:nvPr/>
+        </p:nvPicPr>
+        <p:blipFill>
+          <a:blip r:embed="rId2"/>
+          <a:stretch>
+            <a:fillRect/>
+          </a:stretch>
+        </p:blipFill>
+        <p:spPr>
+          <a:xfrm>
+            <a:off x="6263640" y="1234440"/>
+            <a:ext cx="5440680" cy="3104670"/>
+          </a:xfrm>
+          <a:prstGeom prst="rect">
+            <a:avLst/>
+          </a:prstGeom>
+        </p:spPr>
+      </p:pic>
     </p:spTree>
   </p:cSld>
   <p:clrMapOvr>
@@ -6277,6 +5958,814 @@
             <a:avLst/>
           </a:prstGeom>
           <a:solidFill>
+            <a:srgbClr val="EFE6D3"/>
+          </a:solidFill>
+          <a:ln>
+            <a:noFill/>
+          </a:ln>
+        </p:spPr>
+        <p:style>
+          <a:lnRef idx="1">
+            <a:schemeClr val="accent1"/>
+          </a:lnRef>
+          <a:fillRef idx="3">
+            <a:schemeClr val="accent1"/>
+          </a:fillRef>
+          <a:effectRef idx="2">
+            <a:schemeClr val="accent1"/>
+          </a:effectRef>
+          <a:fontRef idx="minor">
+            <a:schemeClr val="lt1"/>
+          </a:fontRef>
+        </p:style>
+        <p:txBody>
+          <a:bodyPr rtlCol="0" anchor="ctr"/>
+          <a:lstStyle/>
+          <a:p>
+            <a:pPr algn="ctr"/>
+          </a:p>
+        </p:txBody>
+      </p:sp>
+      <p:sp>
+        <p:nvSpPr>
+          <p:cNvPr id="3" name="Rectangle 2"/>
+          <p:cNvSpPr/>
+          <p:nvPr/>
+        </p:nvSpPr>
+        <p:spPr>
+          <a:xfrm>
+            <a:off x="0" y="0"/>
+            <a:ext cx="12191695" cy="109728"/>
+          </a:xfrm>
+          <a:prstGeom prst="rect">
+            <a:avLst/>
+          </a:prstGeom>
+          <a:solidFill>
+            <a:srgbClr val="171B22"/>
+          </a:solidFill>
+          <a:ln>
+            <a:noFill/>
+          </a:ln>
+        </p:spPr>
+        <p:style>
+          <a:lnRef idx="1">
+            <a:schemeClr val="accent1"/>
+          </a:lnRef>
+          <a:fillRef idx="3">
+            <a:schemeClr val="accent1"/>
+          </a:fillRef>
+          <a:effectRef idx="2">
+            <a:schemeClr val="accent1"/>
+          </a:effectRef>
+          <a:fontRef idx="minor">
+            <a:schemeClr val="lt1"/>
+          </a:fontRef>
+        </p:style>
+        <p:txBody>
+          <a:bodyPr rtlCol="0" anchor="ctr"/>
+          <a:lstStyle/>
+          <a:p>
+            <a:pPr algn="ctr"/>
+          </a:p>
+        </p:txBody>
+      </p:sp>
+      <p:sp>
+        <p:nvSpPr>
+          <p:cNvPr id="4" name="TextBox 3"/>
+          <p:cNvSpPr txBox="1"/>
+          <p:nvPr/>
+        </p:nvSpPr>
+        <p:spPr>
+          <a:xfrm>
+            <a:off x="502920" y="201168"/>
+            <a:ext cx="11155680" cy="868680"/>
+          </a:xfrm>
+          <a:prstGeom prst="rect">
+            <a:avLst/>
+          </a:prstGeom>
+          <a:noFill/>
+        </p:spPr>
+        <p:txBody>
+          <a:bodyPr wrap="square">
+            <a:spAutoFit/>
+          </a:bodyPr>
+          <a:lstStyle/>
+          <a:p>
+            <a:pPr algn="l">
+              <a:spcAft>
+                <a:spcPts val="200"/>
+              </a:spcAft>
+            </a:pPr>
+            <a:r>
+              <a:rPr sz="1200" b="1" i="0">
+                <a:solidFill>
+                  <a:srgbClr val="8C2F39"/>
+                </a:solidFill>
+                <a:latin typeface="Calibri"/>
+              </a:rPr>
+              <a:t>TASK 4  ·  GOALKEEPER AGE</a:t>
+            </a:r>
+          </a:p>
+          <a:p>
+            <a:pPr algn="l">
+              <a:spcAft>
+                <a:spcPts val="0"/>
+              </a:spcAft>
+            </a:pPr>
+            <a:r>
+              <a:rPr sz="2400" b="0" i="1">
+                <a:solidFill>
+                  <a:srgbClr val="171B22"/>
+                </a:solidFill>
+                <a:latin typeface="Georgia"/>
+              </a:rPr>
+              <a:t>Do keepers last past the outfield “prime” of 27?</a:t>
+            </a:r>
+          </a:p>
+        </p:txBody>
+      </p:sp>
+      <p:sp>
+        <p:nvSpPr>
+          <p:cNvPr id="5" name="TextBox 4"/>
+          <p:cNvSpPr txBox="1"/>
+          <p:nvPr/>
+        </p:nvSpPr>
+        <p:spPr>
+          <a:xfrm>
+            <a:off x="502920" y="1143000"/>
+            <a:ext cx="5623560" cy="5303520"/>
+          </a:xfrm>
+          <a:prstGeom prst="rect">
+            <a:avLst/>
+          </a:prstGeom>
+          <a:noFill/>
+        </p:spPr>
+        <p:txBody>
+          <a:bodyPr wrap="square">
+            <a:spAutoFit/>
+          </a:bodyPr>
+          <a:lstStyle/>
+          <a:p>
+            <a:pPr algn="l">
+              <a:spcAft>
+                <a:spcPts val="400"/>
+              </a:spcAft>
+            </a:pPr>
+            <a:r>
+              <a:rPr sz="1300" b="1" i="0">
+                <a:solidFill>
+                  <a:srgbClr val="8C2F39"/>
+                </a:solidFill>
+                <a:latin typeface="Calibri"/>
+              </a:rPr>
+              <a:t>The story people tell</a:t>
+            </a:r>
+          </a:p>
+          <a:p>
+            <a:pPr algn="l">
+              <a:spcAft>
+                <a:spcPts val="1200"/>
+              </a:spcAft>
+            </a:pPr>
+            <a:r>
+              <a:rPr sz="1500" b="0" i="0">
+                <a:solidFill>
+                  <a:srgbClr val="171B22"/>
+                </a:solidFill>
+                <a:latin typeface="Calibri"/>
+              </a:rPr>
+              <a:t>Goalkeepers peak later and keep their place into their thirties, unlike outfield players.</a:t>
+            </a:r>
+          </a:p>
+          <a:p>
+            <a:pPr algn="l">
+              <a:spcAft>
+                <a:spcPts val="400"/>
+              </a:spcAft>
+            </a:pPr>
+            <a:r>
+              <a:rPr sz="1300" b="1" i="0">
+                <a:solidFill>
+                  <a:srgbClr val="8C2F39"/>
+                </a:solidFill>
+                <a:latin typeface="Calibri"/>
+              </a:rPr>
+              <a:t>How we tested it</a:t>
+            </a:r>
+          </a:p>
+          <a:p>
+            <a:pPr algn="l">
+              <a:spcAft>
+                <a:spcPts val="1200"/>
+              </a:spcAft>
+            </a:pPr>
+            <a:r>
+              <a:rPr sz="1500" b="0" i="0">
+                <a:solidFill>
+                  <a:srgbClr val="171B22"/>
+                </a:solidFill>
+                <a:latin typeface="Calibri"/>
+              </a:rPr>
+              <a:t>One-sample t-test of keepers who appeared (n = 40) against a fixed 27-year benchmark. Then a supporting two-sample comparison with 40 outfield players.</a:t>
+            </a:r>
+          </a:p>
+          <a:p>
+            <a:pPr algn="l">
+              <a:spcAft>
+                <a:spcPts val="400"/>
+              </a:spcAft>
+            </a:pPr>
+            <a:r>
+              <a:rPr sz="1300" b="1" i="0">
+                <a:solidFill>
+                  <a:srgbClr val="8C2F39"/>
+                </a:solidFill>
+                <a:latin typeface="Calibri"/>
+              </a:rPr>
+              <a:t>What the chart shows</a:t>
+            </a:r>
+          </a:p>
+          <a:p>
+            <a:pPr algn="l">
+              <a:spcAft>
+                <a:spcPts val="1200"/>
+              </a:spcAft>
+            </a:pPr>
+            <a:r>
+              <a:rPr sz="1500" b="0" i="0">
+                <a:solidFill>
+                  <a:srgbClr val="171B22"/>
+                </a:solidFill>
+                <a:latin typeface="Calibri"/>
+              </a:rPr>
+              <a:t>The dashed line is 27. The keeper box sits clearly above it. Mean 30.3 years; 95% CI (28.7, 31.9).</a:t>
+            </a:r>
+          </a:p>
+          <a:p>
+            <a:pPr algn="l">
+              <a:spcAft>
+                <a:spcPts val="400"/>
+              </a:spcAft>
+            </a:pPr>
+            <a:r>
+              <a:rPr sz="1300" b="1" i="0">
+                <a:solidFill>
+                  <a:srgbClr val="8C2F39"/>
+                </a:solidFill>
+                <a:latin typeface="Calibri"/>
+              </a:rPr>
+              <a:t>Decision</a:t>
+            </a:r>
+          </a:p>
+          <a:p>
+            <a:pPr algn="l">
+              <a:spcAft>
+                <a:spcPts val="0"/>
+              </a:spcAft>
+            </a:pPr>
+            <a:r>
+              <a:rPr sz="1600" b="1" i="0">
+                <a:solidFill>
+                  <a:srgbClr val="171B22"/>
+                </a:solidFill>
+                <a:latin typeface="Calibri"/>
+              </a:rPr>
+              <a:t>p = 0.0001 vs 27. Also 3.6 years older than outfielders (p = 0.0004). Longer shelf life is real.</a:t>
+            </a:r>
+          </a:p>
+        </p:txBody>
+      </p:sp>
+      <p:pic>
+        <p:nvPicPr>
+          <p:cNvPr id="6" name="Picture 5" descr="task4_age.png"/>
+          <p:cNvPicPr>
+            <a:picLocks noChangeAspect="1"/>
+          </p:cNvPicPr>
+          <p:nvPr/>
+        </p:nvPicPr>
+        <p:blipFill>
+          <a:blip r:embed="rId2"/>
+          <a:stretch>
+            <a:fillRect/>
+          </a:stretch>
+        </p:blipFill>
+        <p:spPr>
+          <a:xfrm>
+            <a:off x="6263640" y="1234440"/>
+            <a:ext cx="5440680" cy="3091840"/>
+          </a:xfrm>
+          <a:prstGeom prst="rect">
+            <a:avLst/>
+          </a:prstGeom>
+        </p:spPr>
+      </p:pic>
+    </p:spTree>
+  </p:cSld>
+  <p:clrMapOvr>
+    <a:masterClrMapping/>
+  </p:clrMapOvr>
+</p:sld>
+</file>
+
+<file path=ppt/slides/slide7.xml><?xml version="1.0" encoding="utf-8"?>
+<p:sld xmlns:a="http://schemas.openxmlformats.org/drawingml/2006/main" xmlns:p="http://schemas.openxmlformats.org/presentationml/2006/main" xmlns:r="http://schemas.openxmlformats.org/officeDocument/2006/relationships">
+  <p:cSld>
+    <p:spTree>
+      <p:nvGrpSpPr>
+        <p:cNvPr id="1" name=""/>
+        <p:cNvGrpSpPr/>
+        <p:nvPr/>
+      </p:nvGrpSpPr>
+      <p:grpSpPr/>
+      <p:sp>
+        <p:nvSpPr>
+          <p:cNvPr id="2" name="Rectangle 1"/>
+          <p:cNvSpPr/>
+          <p:nvPr/>
+        </p:nvSpPr>
+        <p:spPr>
+          <a:xfrm>
+            <a:off x="0" y="0"/>
+            <a:ext cx="12191695" cy="6858000"/>
+          </a:xfrm>
+          <a:prstGeom prst="rect">
+            <a:avLst/>
+          </a:prstGeom>
+          <a:solidFill>
+            <a:srgbClr val="EFE6D3"/>
+          </a:solidFill>
+          <a:ln>
+            <a:noFill/>
+          </a:ln>
+        </p:spPr>
+        <p:style>
+          <a:lnRef idx="1">
+            <a:schemeClr val="accent1"/>
+          </a:lnRef>
+          <a:fillRef idx="3">
+            <a:schemeClr val="accent1"/>
+          </a:fillRef>
+          <a:effectRef idx="2">
+            <a:schemeClr val="accent1"/>
+          </a:effectRef>
+          <a:fontRef idx="minor">
+            <a:schemeClr val="lt1"/>
+          </a:fontRef>
+        </p:style>
+        <p:txBody>
+          <a:bodyPr rtlCol="0" anchor="ctr"/>
+          <a:lstStyle/>
+          <a:p>
+            <a:pPr algn="ctr"/>
+          </a:p>
+        </p:txBody>
+      </p:sp>
+      <p:sp>
+        <p:nvSpPr>
+          <p:cNvPr id="3" name="Rectangle 2"/>
+          <p:cNvSpPr/>
+          <p:nvPr/>
+        </p:nvSpPr>
+        <p:spPr>
+          <a:xfrm>
+            <a:off x="0" y="0"/>
+            <a:ext cx="12191695" cy="109728"/>
+          </a:xfrm>
+          <a:prstGeom prst="rect">
+            <a:avLst/>
+          </a:prstGeom>
+          <a:solidFill>
+            <a:srgbClr val="171B22"/>
+          </a:solidFill>
+          <a:ln>
+            <a:noFill/>
+          </a:ln>
+        </p:spPr>
+        <p:style>
+          <a:lnRef idx="1">
+            <a:schemeClr val="accent1"/>
+          </a:lnRef>
+          <a:fillRef idx="3">
+            <a:schemeClr val="accent1"/>
+          </a:fillRef>
+          <a:effectRef idx="2">
+            <a:schemeClr val="accent1"/>
+          </a:effectRef>
+          <a:fontRef idx="minor">
+            <a:schemeClr val="lt1"/>
+          </a:fontRef>
+        </p:style>
+        <p:txBody>
+          <a:bodyPr rtlCol="0" anchor="ctr"/>
+          <a:lstStyle/>
+          <a:p>
+            <a:pPr algn="ctr"/>
+          </a:p>
+        </p:txBody>
+      </p:sp>
+      <p:sp>
+        <p:nvSpPr>
+          <p:cNvPr id="4" name="TextBox 3"/>
+          <p:cNvSpPr txBox="1"/>
+          <p:nvPr/>
+        </p:nvSpPr>
+        <p:spPr>
+          <a:xfrm>
+            <a:off x="502920" y="201168"/>
+            <a:ext cx="11155680" cy="868680"/>
+          </a:xfrm>
+          <a:prstGeom prst="rect">
+            <a:avLst/>
+          </a:prstGeom>
+          <a:noFill/>
+        </p:spPr>
+        <p:txBody>
+          <a:bodyPr wrap="square">
+            <a:spAutoFit/>
+          </a:bodyPr>
+          <a:lstStyle/>
+          <a:p>
+            <a:pPr algn="l">
+              <a:spcAft>
+                <a:spcPts val="200"/>
+              </a:spcAft>
+            </a:pPr>
+            <a:r>
+              <a:rPr sz="1200" b="1" i="0">
+                <a:solidFill>
+                  <a:srgbClr val="8C2F39"/>
+                </a:solidFill>
+                <a:latin typeface="Calibri"/>
+              </a:rPr>
+              <a:t>OBJECTIVE 2  ·  TWO PRE-MATCH MODELS</a:t>
+            </a:r>
+          </a:p>
+          <a:p>
+            <a:pPr algn="l">
+              <a:spcAft>
+                <a:spcPts val="0"/>
+              </a:spcAft>
+            </a:pPr>
+            <a:r>
+              <a:rPr sz="2400" b="0" i="1">
+                <a:solidFill>
+                  <a:srgbClr val="171B22"/>
+                </a:solidFill>
+                <a:latin typeface="Georgia"/>
+              </a:rPr>
+              <a:t>Can we predict the score before kickoff?</a:t>
+            </a:r>
+          </a:p>
+        </p:txBody>
+      </p:sp>
+      <p:sp>
+        <p:nvSpPr>
+          <p:cNvPr id="5" name="TextBox 4"/>
+          <p:cNvSpPr txBox="1"/>
+          <p:nvPr/>
+        </p:nvSpPr>
+        <p:spPr>
+          <a:xfrm>
+            <a:off x="502920" y="1078992"/>
+            <a:ext cx="11155680" cy="640080"/>
+          </a:xfrm>
+          <a:prstGeom prst="rect">
+            <a:avLst/>
+          </a:prstGeom>
+          <a:noFill/>
+        </p:spPr>
+        <p:txBody>
+          <a:bodyPr wrap="square">
+            <a:spAutoFit/>
+          </a:bodyPr>
+          <a:lstStyle/>
+          <a:p>
+            <a:pPr algn="l">
+              <a:spcAft>
+                <a:spcPts val="0"/>
+              </a:spcAft>
+            </a:pPr>
+            <a:r>
+              <a:rPr sz="1400" b="0" i="0">
+                <a:solidFill>
+                  <a:srgbClr val="584F44"/>
+                </a:solidFill>
+                <a:latin typeface="Calibri"/>
+              </a:rPr>
+              <a:t>Eight explanatory variables in each model, all knowable before the match — ranking, squad value, age, host, rest, confederation, knockout. No shots. No possession.</a:t>
+            </a:r>
+          </a:p>
+        </p:txBody>
+      </p:sp>
+      <p:sp>
+        <p:nvSpPr>
+          <p:cNvPr id="6" name="Rectangle 5"/>
+          <p:cNvSpPr/>
+          <p:nvPr/>
+        </p:nvSpPr>
+        <p:spPr>
+          <a:xfrm>
+            <a:off x="457200" y="1783080"/>
+            <a:ext cx="5532120" cy="1234440"/>
+          </a:xfrm>
+          <a:prstGeom prst="rect">
+            <a:avLst/>
+          </a:prstGeom>
+          <a:solidFill>
+            <a:srgbClr val="171B22"/>
+          </a:solidFill>
+          <a:ln>
+            <a:noFill/>
+          </a:ln>
+        </p:spPr>
+        <p:style>
+          <a:lnRef idx="1">
+            <a:schemeClr val="accent1"/>
+          </a:lnRef>
+          <a:fillRef idx="3">
+            <a:schemeClr val="accent1"/>
+          </a:fillRef>
+          <a:effectRef idx="2">
+            <a:schemeClr val="accent1"/>
+          </a:effectRef>
+          <a:fontRef idx="minor">
+            <a:schemeClr val="lt1"/>
+          </a:fontRef>
+        </p:style>
+        <p:txBody>
+          <a:bodyPr rtlCol="0" anchor="ctr"/>
+          <a:lstStyle/>
+          <a:p>
+            <a:pPr algn="ctr"/>
+          </a:p>
+        </p:txBody>
+      </p:sp>
+      <p:sp>
+        <p:nvSpPr>
+          <p:cNvPr id="7" name="TextBox 6"/>
+          <p:cNvSpPr txBox="1"/>
+          <p:nvPr/>
+        </p:nvSpPr>
+        <p:spPr>
+          <a:xfrm>
+            <a:off x="594360" y="1874519"/>
+            <a:ext cx="5257800" cy="1097280"/>
+          </a:xfrm>
+          <a:prstGeom prst="rect">
+            <a:avLst/>
+          </a:prstGeom>
+          <a:noFill/>
+        </p:spPr>
+        <p:txBody>
+          <a:bodyPr wrap="square">
+            <a:spAutoFit/>
+          </a:bodyPr>
+          <a:lstStyle/>
+          <a:p>
+            <a:pPr algn="l">
+              <a:spcAft>
+                <a:spcPts val="200"/>
+              </a:spcAft>
+            </a:pPr>
+            <a:r>
+              <a:rPr sz="1400" b="1" i="0">
+                <a:solidFill>
+                  <a:srgbClr val="D9A544"/>
+                </a:solidFill>
+                <a:latin typeface="Calibri"/>
+              </a:rPr>
+              <a:t>2.1  Goal difference  ·  104 matches</a:t>
+            </a:r>
+          </a:p>
+          <a:p>
+            <a:pPr algn="l">
+              <a:spcAft>
+                <a:spcPts val="200"/>
+              </a:spcAft>
+            </a:pPr>
+            <a:r>
+              <a:rPr sz="1300" b="0" i="0">
+                <a:solidFill>
+                  <a:srgbClr val="EFE6D3"/>
+                </a:solidFill>
+                <a:latin typeface="Calibri"/>
+              </a:rPr>
+              <a:t>R² = 0.49   ·   test RMSE 1.57 goals</a:t>
+            </a:r>
+          </a:p>
+          <a:p>
+            <a:pPr algn="l">
+              <a:spcAft>
+                <a:spcPts val="0"/>
+              </a:spcAft>
+            </a:pPr>
+            <a:r>
+              <a:rPr sz="1300" b="0" i="0">
+                <a:solidFill>
+                  <a:srgbClr val="FFFFFF"/>
+                </a:solidFill>
+                <a:latin typeface="Calibri"/>
+              </a:rPr>
+              <a:t>Significant: FIFA rank gap, squad-value gap</a:t>
+            </a:r>
+          </a:p>
+        </p:txBody>
+      </p:sp>
+      <p:sp>
+        <p:nvSpPr>
+          <p:cNvPr id="8" name="Rectangle 7"/>
+          <p:cNvSpPr/>
+          <p:nvPr/>
+        </p:nvSpPr>
+        <p:spPr>
+          <a:xfrm>
+            <a:off x="6172200" y="1783080"/>
+            <a:ext cx="5532120" cy="1234440"/>
+          </a:xfrm>
+          <a:prstGeom prst="rect">
+            <a:avLst/>
+          </a:prstGeom>
+          <a:solidFill>
+            <a:srgbClr val="24402C"/>
+          </a:solidFill>
+          <a:ln>
+            <a:noFill/>
+          </a:ln>
+        </p:spPr>
+        <p:style>
+          <a:lnRef idx="1">
+            <a:schemeClr val="accent1"/>
+          </a:lnRef>
+          <a:fillRef idx="3">
+            <a:schemeClr val="accent1"/>
+          </a:fillRef>
+          <a:effectRef idx="2">
+            <a:schemeClr val="accent1"/>
+          </a:effectRef>
+          <a:fontRef idx="minor">
+            <a:schemeClr val="lt1"/>
+          </a:fontRef>
+        </p:style>
+        <p:txBody>
+          <a:bodyPr rtlCol="0" anchor="ctr"/>
+          <a:lstStyle/>
+          <a:p>
+            <a:pPr algn="ctr"/>
+          </a:p>
+        </p:txBody>
+      </p:sp>
+      <p:sp>
+        <p:nvSpPr>
+          <p:cNvPr id="9" name="TextBox 8"/>
+          <p:cNvSpPr txBox="1"/>
+          <p:nvPr/>
+        </p:nvSpPr>
+        <p:spPr>
+          <a:xfrm>
+            <a:off x="6309360" y="1874519"/>
+            <a:ext cx="5257800" cy="1097280"/>
+          </a:xfrm>
+          <a:prstGeom prst="rect">
+            <a:avLst/>
+          </a:prstGeom>
+          <a:noFill/>
+        </p:spPr>
+        <p:txBody>
+          <a:bodyPr wrap="square">
+            <a:spAutoFit/>
+          </a:bodyPr>
+          <a:lstStyle/>
+          <a:p>
+            <a:pPr algn="l">
+              <a:spcAft>
+                <a:spcPts val="200"/>
+              </a:spcAft>
+            </a:pPr>
+            <a:r>
+              <a:rPr sz="1400" b="1" i="0">
+                <a:solidFill>
+                  <a:srgbClr val="D9A544"/>
+                </a:solidFill>
+                <a:latin typeface="Calibri"/>
+              </a:rPr>
+              <a:t>2.2  Team goals  ·  208 team-matches</a:t>
+            </a:r>
+          </a:p>
+          <a:p>
+            <a:pPr algn="l">
+              <a:spcAft>
+                <a:spcPts val="200"/>
+              </a:spcAft>
+            </a:pPr>
+            <a:r>
+              <a:rPr sz="1300" b="0" i="0">
+                <a:solidFill>
+                  <a:srgbClr val="EFE6D3"/>
+                </a:solidFill>
+                <a:latin typeface="Calibri"/>
+              </a:rPr>
+              <a:t>R² = 0.29   ·   test RMSE 1.23 goals</a:t>
+            </a:r>
+          </a:p>
+          <a:p>
+            <a:pPr algn="l">
+              <a:spcAft>
+                <a:spcPts val="0"/>
+              </a:spcAft>
+            </a:pPr>
+            <a:r>
+              <a:rPr sz="1300" b="0" i="0">
+                <a:solidFill>
+                  <a:srgbClr val="FFFFFF"/>
+                </a:solidFill>
+                <a:latin typeface="Calibri"/>
+              </a:rPr>
+              <a:t>Significant: opponent rank, own squad value</a:t>
+            </a:r>
+          </a:p>
+        </p:txBody>
+      </p:sp>
+      <p:pic>
+        <p:nvPicPr>
+          <p:cNvPr id="10" name="Picture 9" descr="reg1_pred.png"/>
+          <p:cNvPicPr>
+            <a:picLocks noChangeAspect="1"/>
+          </p:cNvPicPr>
+          <p:nvPr/>
+        </p:nvPicPr>
+        <p:blipFill>
+          <a:blip r:embed="rId2"/>
+          <a:stretch>
+            <a:fillRect/>
+          </a:stretch>
+        </p:blipFill>
+        <p:spPr>
+          <a:xfrm>
+            <a:off x="457200" y="3154680"/>
+            <a:ext cx="5532120" cy="5539607"/>
+          </a:xfrm>
+          <a:prstGeom prst="rect">
+            <a:avLst/>
+          </a:prstGeom>
+        </p:spPr>
+      </p:pic>
+      <p:pic>
+        <p:nvPicPr>
+          <p:cNvPr id="11" name="Picture 10" descr="reg2_pred.png"/>
+          <p:cNvPicPr>
+            <a:picLocks noChangeAspect="1"/>
+          </p:cNvPicPr>
+          <p:nvPr/>
+        </p:nvPicPr>
+        <p:blipFill>
+          <a:blip r:embed="rId3"/>
+          <a:stretch>
+            <a:fillRect/>
+          </a:stretch>
+        </p:blipFill>
+        <p:spPr>
+          <a:xfrm>
+            <a:off x="6172200" y="3154680"/>
+            <a:ext cx="5532120" cy="5532120"/>
+          </a:xfrm>
+          <a:prstGeom prst="rect">
+            <a:avLst/>
+          </a:prstGeom>
+        </p:spPr>
+      </p:pic>
+    </p:spTree>
+  </p:cSld>
+  <p:clrMapOvr>
+    <a:masterClrMapping/>
+  </p:clrMapOvr>
+</p:sld>
+</file>
+
+<file path=ppt/slides/slide8.xml><?xml version="1.0" encoding="utf-8"?>
+<p:sld xmlns:a="http://schemas.openxmlformats.org/drawingml/2006/main" xmlns:p="http://schemas.openxmlformats.org/presentationml/2006/main" xmlns:r="http://schemas.openxmlformats.org/officeDocument/2006/relationships">
+  <p:cSld>
+    <p:spTree>
+      <p:nvGrpSpPr>
+        <p:cNvPr id="1" name=""/>
+        <p:cNvGrpSpPr/>
+        <p:nvPr/>
+      </p:nvGrpSpPr>
+      <p:grpSpPr/>
+      <p:sp>
+        <p:nvSpPr>
+          <p:cNvPr id="2" name="Rectangle 1"/>
+          <p:cNvSpPr/>
+          <p:nvPr/>
+        </p:nvSpPr>
+        <p:spPr>
+          <a:xfrm>
+            <a:off x="0" y="0"/>
+            <a:ext cx="12191695" cy="6858000"/>
+          </a:xfrm>
+          <a:prstGeom prst="rect">
+            <a:avLst/>
+          </a:prstGeom>
+          <a:solidFill>
             <a:srgbClr val="171B22"/>
           </a:solidFill>
           <a:ln>
@@ -6399,7 +6888,7 @@
         </p:nvSpPr>
         <p:spPr>
           <a:xfrm>
-            <a:off x="731520" y="502920"/>
+            <a:off x="731520" y="411480"/>
             <a:ext cx="10607040" cy="822960"/>
           </a:xfrm>
           <a:prstGeom prst="rect">
@@ -6425,23 +6914,23 @@
                 </a:solidFill>
                 <a:latin typeface="Calibri"/>
               </a:rPr>
-              <a:t>IF YOU REMEMBER THREE THINGS</a:t>
+              <a:t>WALK-AWAY POINTS</a:t>
             </a:r>
           </a:p>
           <a:p>
             <a:pPr algn="l">
               <a:spcAft>
-                <a:spcPts val="400"/>
+                <a:spcPts val="0"/>
               </a:spcAft>
             </a:pPr>
             <a:r>
-              <a:rPr sz="3200" b="0" i="1">
+              <a:rPr sz="3000" b="0" i="1">
                 <a:solidFill>
                   <a:srgbClr val="EFE6D3"/>
                 </a:solidFill>
                 <a:latin typeface="Georgia"/>
               </a:rPr>
-              <a:t>Walk-away points</a:t>
+              <a:t>What survived the tests</a:t>
             </a:r>
           </a:p>
         </p:txBody>
@@ -6454,7 +6943,7 @@
         </p:nvSpPr>
         <p:spPr>
           <a:xfrm>
-            <a:off x="777240" y="1554480"/>
+            <a:off x="777240" y="1417320"/>
             <a:ext cx="640080" cy="640080"/>
           </a:xfrm>
           <a:prstGeom prst="rect">
@@ -6497,7 +6986,7 @@
         </p:nvSpPr>
         <p:spPr>
           <a:xfrm>
-            <a:off x="777240" y="1664208"/>
+            <a:off x="777240" y="1527048"/>
             <a:ext cx="640080" cy="457200"/>
           </a:xfrm>
           <a:prstGeom prst="rect">
@@ -6513,7 +7002,7 @@
           <a:p>
             <a:pPr algn="ctr">
               <a:spcAft>
-                <a:spcPts val="400"/>
+                <a:spcPts val="0"/>
               </a:spcAft>
             </a:pPr>
             <a:r>
@@ -6536,8 +7025,8 @@
         </p:nvSpPr>
         <p:spPr>
           <a:xfrm>
-            <a:off x="1645920" y="1554480"/>
-            <a:ext cx="9601200" cy="1234440"/>
+            <a:off x="1645920" y="1417320"/>
+            <a:ext cx="9601200" cy="1371600"/>
           </a:xfrm>
           <a:prstGeom prst="rect">
             <a:avLst/>
@@ -6552,7 +7041,7 @@
           <a:p>
             <a:pPr algn="l">
               <a:spcAft>
-                <a:spcPts val="400"/>
+                <a:spcPts val="600"/>
               </a:spcAft>
             </a:pPr>
             <a:r>
@@ -6568,7 +7057,7 @@
           <a:p>
             <a:pPr algn="l">
               <a:spcAft>
-                <a:spcPts val="400"/>
+                <a:spcPts val="0"/>
               </a:spcAft>
             </a:pPr>
             <a:r>
@@ -6578,7 +7067,7 @@
                 </a:solidFill>
                 <a:latin typeface="Calibri"/>
               </a:rPr>
-              <a:t>Group and knockout attendance were statistically the same.</a:t>
+              <a:t>Group and knockout attendance were statistically the same. The 48-team format still filled grounds.</a:t>
             </a:r>
           </a:p>
         </p:txBody>
@@ -6650,7 +7139,7 @@
           <a:p>
             <a:pPr algn="ctr">
               <a:spcAft>
-                <a:spcPts val="400"/>
+                <a:spcPts val="0"/>
               </a:spcAft>
             </a:pPr>
             <a:r>
@@ -6674,7 +7163,7 @@
         <p:spPr>
           <a:xfrm>
             <a:off x="1645920" y="2971800"/>
-            <a:ext cx="9601200" cy="1234440"/>
+            <a:ext cx="9601200" cy="1371600"/>
           </a:xfrm>
           <a:prstGeom prst="rect">
             <a:avLst/>
@@ -6689,7 +7178,7 @@
           <a:p>
             <a:pPr algn="l">
               <a:spcAft>
-                <a:spcPts val="400"/>
+                <a:spcPts val="600"/>
               </a:spcAft>
             </a:pPr>
             <a:r>
@@ -6705,7 +7194,7 @@
           <a:p>
             <a:pPr algn="l">
               <a:spcAft>
-                <a:spcPts val="400"/>
+                <a:spcPts val="0"/>
               </a:spcAft>
             </a:pPr>
             <a:r>
@@ -6715,7 +7204,7 @@
                 </a:solidFill>
                 <a:latin typeface="Calibri"/>
               </a:rPr>
-              <a:t>UEFA squads ~2.6× the market value of the rest.</a:t>
+              <a:t>UEFA squads were about 2.6 times more valuable. Keepers were also clearly older than 27.</a:t>
             </a:r>
           </a:p>
         </p:txBody>
@@ -6728,7 +7217,7 @@
         </p:nvSpPr>
         <p:spPr>
           <a:xfrm>
-            <a:off x="777240" y="4389120"/>
+            <a:off x="777240" y="4526280"/>
             <a:ext cx="640080" cy="640080"/>
           </a:xfrm>
           <a:prstGeom prst="rect">
@@ -6771,7 +7260,7 @@
         </p:nvSpPr>
         <p:spPr>
           <a:xfrm>
-            <a:off x="777240" y="4498848"/>
+            <a:off x="777240" y="4636008"/>
             <a:ext cx="640080" cy="457200"/>
           </a:xfrm>
           <a:prstGeom prst="rect">
@@ -6787,7 +7276,7 @@
           <a:p>
             <a:pPr algn="ctr">
               <a:spcAft>
-                <a:spcPts val="400"/>
+                <a:spcPts val="0"/>
               </a:spcAft>
             </a:pPr>
             <a:r>
@@ -6810,8 +7299,8 @@
         </p:nvSpPr>
         <p:spPr>
           <a:xfrm>
-            <a:off x="1645920" y="4389120"/>
-            <a:ext cx="9601200" cy="1234440"/>
+            <a:off x="1645920" y="4526280"/>
+            <a:ext cx="9601200" cy="1371600"/>
           </a:xfrm>
           <a:prstGeom prst="rect">
             <a:avLst/>
@@ -6826,7 +7315,7 @@
           <a:p>
             <a:pPr algn="l">
               <a:spcAft>
-                <a:spcPts val="400"/>
+                <a:spcPts val="600"/>
               </a:spcAft>
             </a:pPr>
             <a:r>
@@ -6842,7 +7331,7 @@
           <a:p>
             <a:pPr algn="l">
               <a:spcAft>
-                <a:spcPts val="400"/>
+                <a:spcPts val="0"/>
               </a:spcAft>
             </a:pPr>
             <a:r>
@@ -6852,7 +7341,7 @@
                 </a:solidFill>
                 <a:latin typeface="Calibri"/>
               </a:rPr>
-              <a:t>They predict goal difference. Host, rest, and age do not.</a:t>
+              <a:t>They predict goal difference and goals. Host, rest and age drop out once those two are in the model.</a:t>
             </a:r>
           </a:p>
         </p:txBody>

</xml_diff>